<commit_message>
Fix diagram mappings to use genuine System Architecture & DFD, unify presentation colors to academic navy
</commit_message>
<xml_diff>
--- a/University_Submissions/24BCE1836_NetworkSim_Presentation.pptx
+++ b/University_Submissions/24BCE1836_NetworkSim_Presentation.pptx
@@ -3254,9 +3254,9 @@
               <a:spcAft>
                 <a:spcPts val="1400"/>
               </a:spcAft>
-              <a:defRPr sz="1500">
-                <a:solidFill>
-                  <a:srgbClr val="1D4ED8"/>
+              <a:defRPr sz="1400">
+                <a:solidFill>
+                  <a:srgbClr val="1E3A8A"/>
                 </a:solidFill>
                 <a:latin typeface="Arial"/>
               </a:defRPr>
@@ -3318,14 +3318,14 @@
           </a:fontRef>
         </p:style>
         <p:txBody>
-          <a:bodyPr rtlCol="0" anchor="t" wrap="square" lIns="228600" rIns="228600" tIns="201168" bIns="182880"/>
+          <a:bodyPr rtlCol="0" anchor="t" wrap="square" lIns="228600" rIns="228600" tIns="164592" bIns="164592"/>
           <a:lstStyle/>
           <a:p>
             <a:pPr algn="ctr">
               <a:spcAft>
-                <a:spcPts val="800"/>
+                <a:spcPts val="600"/>
               </a:spcAft>
-              <a:defRPr sz="1400" b="1">
+              <a:defRPr sz="1300" b="1">
                 <a:solidFill>
                   <a:srgbClr val="0F172A"/>
                 </a:solidFill>
@@ -3333,7 +3333,7 @@
               </a:defRPr>
             </a:pPr>
             <a:r>
-              <a:t>Student &amp; Submission Details</a:t>
+              <a:t>Student &amp; Academic Submission Details</a:t>
             </a:r>
           </a:p>
           <a:p>
@@ -3341,7 +3341,7 @@
               <a:lnSpc>
                 <a:spcPct val="125000"/>
               </a:lnSpc>
-              <a:defRPr sz="1100">
+              <a:defRPr sz="1050">
                 <a:solidFill>
                   <a:srgbClr val="334155"/>
                 </a:solidFill>
@@ -3375,13 +3375,13 @@
         <p:spPr>
           <a:xfrm>
             <a:off x="731520" y="4297680"/>
-            <a:ext cx="5212080" cy="73152"/>
-          </a:xfrm>
-          <a:prstGeom prst="rect">
-            <a:avLst/>
-          </a:prstGeom>
-          <a:solidFill>
-            <a:srgbClr val="1D4ED8"/>
+            <a:ext cx="5212080" cy="54864"/>
+          </a:xfrm>
+          <a:prstGeom prst="rect">
+            <a:avLst/>
+          </a:prstGeom>
+          <a:solidFill>
+            <a:srgbClr val="1E3A8A"/>
           </a:solidFill>
           <a:ln>
             <a:noFill/>
@@ -3447,14 +3447,14 @@
           </a:fontRef>
         </p:style>
         <p:txBody>
-          <a:bodyPr rtlCol="0" anchor="t" wrap="square" lIns="228600" rIns="228600" tIns="201168" bIns="182880"/>
+          <a:bodyPr rtlCol="0" anchor="t" wrap="square" lIns="228600" rIns="228600" tIns="164592" bIns="164592"/>
           <a:lstStyle/>
           <a:p>
             <a:pPr algn="ctr">
               <a:spcAft>
-                <a:spcPts val="800"/>
+                <a:spcPts val="600"/>
               </a:spcAft>
-              <a:defRPr sz="1400" b="1">
+              <a:defRPr sz="1300" b="1">
                 <a:solidFill>
                   <a:srgbClr val="0F172A"/>
                 </a:solidFill>
@@ -3462,7 +3462,7 @@
               </a:defRPr>
             </a:pPr>
             <a:r>
-              <a:t>Project Deliverables &amp; Repository</a:t>
+              <a:t>Project Deliverables &amp; Repository Access</a:t>
             </a:r>
           </a:p>
           <a:p>
@@ -3470,7 +3470,7 @@
               <a:lnSpc>
                 <a:spcPct val="125000"/>
               </a:lnSpc>
-              <a:defRPr sz="1100">
+              <a:defRPr sz="1050">
                 <a:solidFill>
                   <a:srgbClr val="334155"/>
                 </a:solidFill>
@@ -3504,7 +3504,7 @@
         <p:spPr>
           <a:xfrm>
             <a:off x="6217920" y="4297680"/>
-            <a:ext cx="5242255" cy="73152"/>
+            <a:ext cx="5242255" cy="54864"/>
           </a:xfrm>
           <a:prstGeom prst="rect">
             <a:avLst/>
@@ -3748,14 +3748,14 @@
           </a:fontRef>
         </p:style>
         <p:txBody>
-          <a:bodyPr rtlCol="0" anchor="t" wrap="square" lIns="228600" rIns="228600" tIns="201168" bIns="182880"/>
+          <a:bodyPr rtlCol="0" anchor="t" wrap="square" lIns="228600" rIns="228600" tIns="164592" bIns="164592"/>
           <a:lstStyle/>
           <a:p>
             <a:pPr algn="ctr">
               <a:spcAft>
-                <a:spcPts val="800"/>
+                <a:spcPts val="600"/>
               </a:spcAft>
-              <a:defRPr sz="1400" b="1">
+              <a:defRPr sz="1300" b="1">
                 <a:solidFill>
                   <a:srgbClr val="0F172A"/>
                 </a:solidFill>
@@ -3771,7 +3771,7 @@
               <a:lnSpc>
                 <a:spcPct val="125000"/>
               </a:lnSpc>
-              <a:defRPr sz="1100">
+              <a:defRPr sz="1050">
                 <a:solidFill>
                   <a:srgbClr val="334155"/>
                 </a:solidFill>
@@ -3793,7 +3793,7 @@
         <p:spPr>
           <a:xfrm>
             <a:off x="731520" y="1554480"/>
-            <a:ext cx="3383280" cy="73152"/>
+            <a:ext cx="3383280" cy="54864"/>
           </a:xfrm>
           <a:prstGeom prst="rect">
             <a:avLst/>
@@ -3865,14 +3865,14 @@
           </a:fontRef>
         </p:style>
         <p:txBody>
-          <a:bodyPr rtlCol="0" anchor="t" wrap="square" lIns="228600" rIns="228600" tIns="201168" bIns="182880"/>
+          <a:bodyPr rtlCol="0" anchor="t" wrap="square" lIns="228600" rIns="228600" tIns="164592" bIns="164592"/>
           <a:lstStyle/>
           <a:p>
             <a:pPr algn="ctr">
               <a:spcAft>
-                <a:spcPts val="800"/>
+                <a:spcPts val="600"/>
               </a:spcAft>
-              <a:defRPr sz="1400" b="1">
+              <a:defRPr sz="1300" b="1">
                 <a:solidFill>
                   <a:srgbClr val="0F172A"/>
                 </a:solidFill>
@@ -3888,7 +3888,7 @@
               <a:lnSpc>
                 <a:spcPct val="125000"/>
               </a:lnSpc>
-              <a:defRPr sz="1100">
+              <a:defRPr sz="1050">
                 <a:solidFill>
                   <a:srgbClr val="334155"/>
                 </a:solidFill>
@@ -3910,13 +3910,13 @@
         <p:spPr>
           <a:xfrm>
             <a:off x="4389120" y="1554480"/>
-            <a:ext cx="3383280" cy="73152"/>
-          </a:xfrm>
-          <a:prstGeom prst="rect">
-            <a:avLst/>
-          </a:prstGeom>
-          <a:solidFill>
-            <a:srgbClr val="1D4ED8"/>
+            <a:ext cx="3383280" cy="54864"/>
+          </a:xfrm>
+          <a:prstGeom prst="rect">
+            <a:avLst/>
+          </a:prstGeom>
+          <a:solidFill>
+            <a:srgbClr val="1E3A8A"/>
           </a:solidFill>
           <a:ln>
             <a:noFill/>
@@ -3982,14 +3982,14 @@
           </a:fontRef>
         </p:style>
         <p:txBody>
-          <a:bodyPr rtlCol="0" anchor="t" wrap="square" lIns="228600" rIns="228600" tIns="201168" bIns="182880"/>
+          <a:bodyPr rtlCol="0" anchor="t" wrap="square" lIns="228600" rIns="228600" tIns="164592" bIns="164592"/>
           <a:lstStyle/>
           <a:p>
             <a:pPr algn="ctr">
               <a:spcAft>
-                <a:spcPts val="800"/>
+                <a:spcPts val="600"/>
               </a:spcAft>
-              <a:defRPr sz="1400" b="1">
+              <a:defRPr sz="1300" b="1">
                 <a:solidFill>
                   <a:srgbClr val="0F172A"/>
                 </a:solidFill>
@@ -4005,7 +4005,7 @@
               <a:lnSpc>
                 <a:spcPct val="125000"/>
               </a:lnSpc>
-              <a:defRPr sz="1100">
+              <a:defRPr sz="1050">
                 <a:solidFill>
                   <a:srgbClr val="334155"/>
                 </a:solidFill>
@@ -4027,13 +4027,13 @@
         <p:spPr>
           <a:xfrm>
             <a:off x="8046720" y="1554480"/>
-            <a:ext cx="3413455" cy="73152"/>
-          </a:xfrm>
-          <a:prstGeom prst="rect">
-            <a:avLst/>
-          </a:prstGeom>
-          <a:solidFill>
-            <a:srgbClr val="16A34A"/>
+            <a:ext cx="3413455" cy="54864"/>
+          </a:xfrm>
+          <a:prstGeom prst="rect">
+            <a:avLst/>
+          </a:prstGeom>
+          <a:solidFill>
+            <a:srgbClr val="1E3A8A"/>
           </a:solidFill>
           <a:ln>
             <a:noFill/>
@@ -4172,7 +4172,7 @@
               </a:defRPr>
             </a:pPr>
             <a:r>
-              <a:t>1. Problem Statement &amp; Scope</a:t>
+              <a:t>1. Problem Statement &amp; Educational Scope</a:t>
             </a:r>
           </a:p>
           <a:p>
@@ -4271,14 +4271,14 @@
           </a:fontRef>
         </p:style>
         <p:txBody>
-          <a:bodyPr rtlCol="0" anchor="t" wrap="square" lIns="228600" rIns="228600" tIns="201168" bIns="182880"/>
+          <a:bodyPr rtlCol="0" anchor="t" wrap="square" lIns="228600" rIns="228600" tIns="164592" bIns="164592"/>
           <a:lstStyle/>
           <a:p>
             <a:pPr algn="ctr">
               <a:spcAft>
-                <a:spcPts val="800"/>
+                <a:spcPts val="600"/>
               </a:spcAft>
-              <a:defRPr sz="1400" b="1">
+              <a:defRPr sz="1300" b="1">
                 <a:solidFill>
                   <a:srgbClr val="0F172A"/>
                 </a:solidFill>
@@ -4294,7 +4294,7 @@
               <a:lnSpc>
                 <a:spcPct val="125000"/>
               </a:lnSpc>
-              <a:defRPr sz="1100">
+              <a:defRPr sz="1050">
                 <a:solidFill>
                   <a:srgbClr val="334155"/>
                 </a:solidFill>
@@ -4316,13 +4316,13 @@
         <p:spPr>
           <a:xfrm>
             <a:off x="731520" y="1554480"/>
-            <a:ext cx="3383280" cy="73152"/>
-          </a:xfrm>
-          <a:prstGeom prst="rect">
-            <a:avLst/>
-          </a:prstGeom>
-          <a:solidFill>
-            <a:srgbClr val="DC2626"/>
+            <a:ext cx="3383280" cy="54864"/>
+          </a:xfrm>
+          <a:prstGeom prst="rect">
+            <a:avLst/>
+          </a:prstGeom>
+          <a:solidFill>
+            <a:srgbClr val="1E3A8A"/>
           </a:solidFill>
           <a:ln>
             <a:noFill/>
@@ -4388,14 +4388,14 @@
           </a:fontRef>
         </p:style>
         <p:txBody>
-          <a:bodyPr rtlCol="0" anchor="t" wrap="square" lIns="228600" rIns="228600" tIns="201168" bIns="182880"/>
+          <a:bodyPr rtlCol="0" anchor="t" wrap="square" lIns="228600" rIns="228600" tIns="164592" bIns="164592"/>
           <a:lstStyle/>
           <a:p>
             <a:pPr algn="ctr">
               <a:spcAft>
-                <a:spcPts val="800"/>
+                <a:spcPts val="600"/>
               </a:spcAft>
-              <a:defRPr sz="1400" b="1">
+              <a:defRPr sz="1300" b="1">
                 <a:solidFill>
                   <a:srgbClr val="0F172A"/>
                 </a:solidFill>
@@ -4411,7 +4411,7 @@
               <a:lnSpc>
                 <a:spcPct val="125000"/>
               </a:lnSpc>
-              <a:defRPr sz="1100">
+              <a:defRPr sz="1050">
                 <a:solidFill>
                   <a:srgbClr val="334155"/>
                 </a:solidFill>
@@ -4433,13 +4433,13 @@
         <p:spPr>
           <a:xfrm>
             <a:off x="4389120" y="1554480"/>
-            <a:ext cx="3383280" cy="73152"/>
-          </a:xfrm>
-          <a:prstGeom prst="rect">
-            <a:avLst/>
-          </a:prstGeom>
-          <a:solidFill>
-            <a:srgbClr val="D97706"/>
+            <a:ext cx="3383280" cy="54864"/>
+          </a:xfrm>
+          <a:prstGeom prst="rect">
+            <a:avLst/>
+          </a:prstGeom>
+          <a:solidFill>
+            <a:srgbClr val="1E3A8A"/>
           </a:solidFill>
           <a:ln>
             <a:noFill/>
@@ -4505,14 +4505,14 @@
           </a:fontRef>
         </p:style>
         <p:txBody>
-          <a:bodyPr rtlCol="0" anchor="t" wrap="square" lIns="228600" rIns="228600" tIns="201168" bIns="182880"/>
+          <a:bodyPr rtlCol="0" anchor="t" wrap="square" lIns="228600" rIns="228600" tIns="164592" bIns="164592"/>
           <a:lstStyle/>
           <a:p>
             <a:pPr algn="ctr">
               <a:spcAft>
-                <a:spcPts val="800"/>
+                <a:spcPts val="600"/>
               </a:spcAft>
-              <a:defRPr sz="1400" b="1">
+              <a:defRPr sz="1300" b="1">
                 <a:solidFill>
                   <a:srgbClr val="0F172A"/>
                 </a:solidFill>
@@ -4528,7 +4528,7 @@
               <a:lnSpc>
                 <a:spcPct val="125000"/>
               </a:lnSpc>
-              <a:defRPr sz="1100">
+              <a:defRPr sz="1050">
                 <a:solidFill>
                   <a:srgbClr val="334155"/>
                 </a:solidFill>
@@ -4550,13 +4550,13 @@
         <p:spPr>
           <a:xfrm>
             <a:off x="8046720" y="1554480"/>
-            <a:ext cx="3413455" cy="73152"/>
-          </a:xfrm>
-          <a:prstGeom prst="rect">
-            <a:avLst/>
-          </a:prstGeom>
-          <a:solidFill>
-            <a:srgbClr val="16A34A"/>
+            <a:ext cx="3413455" cy="54864"/>
+          </a:xfrm>
+          <a:prstGeom prst="rect">
+            <a:avLst/>
+          </a:prstGeom>
+          <a:solidFill>
+            <a:srgbClr val="1E3A8A"/>
           </a:solidFill>
           <a:ln>
             <a:noFill/>
@@ -4708,7 +4708,7 @@
               </a:defRPr>
             </a:pPr>
             <a:r>
-              <a:t>Decoupled 3-Tier Architecture Designed for Sub-Second Interactive Simulation</a:t>
+              <a:t>Core 3-Tier Client-Server Architecture Designed for Real-Time Interactive Simulation</a:t>
             </a:r>
           </a:p>
         </p:txBody>
@@ -4765,7 +4765,7 @@
         <p:spPr>
           <a:xfrm>
             <a:off x="731520" y="1554480"/>
-            <a:ext cx="5212080" cy="4663440"/>
+            <a:ext cx="5577840" cy="4663440"/>
           </a:xfrm>
           <a:prstGeom prst="rect">
             <a:avLst/>
@@ -4817,8 +4817,8 @@
         </p:blipFill>
         <p:spPr>
           <a:xfrm>
-            <a:off x="804672" y="1627632"/>
-            <a:ext cx="5065776" cy="4297680"/>
+            <a:off x="841248" y="2771718"/>
+            <a:ext cx="5358384" cy="1908924"/>
           </a:xfrm>
           <a:prstGeom prst="rect">
             <a:avLst/>
@@ -4834,7 +4834,7 @@
         <p:spPr>
           <a:xfrm>
             <a:off x="731520" y="5897880"/>
-            <a:ext cx="5212080" cy="274320"/>
+            <a:ext cx="5577840" cy="274320"/>
           </a:xfrm>
           <a:prstGeom prst="rect">
             <a:avLst/>
@@ -4850,13 +4850,13 @@
             <a:pPr algn="ctr">
               <a:defRPr sz="950" b="1">
                 <a:solidFill>
-                  <a:srgbClr val="334155"/>
+                  <a:srgbClr val="1E3A8A"/>
                 </a:solidFill>
                 <a:latin typeface="Arial"/>
               </a:defRPr>
             </a:pPr>
             <a:r>
-              <a:t>Fig. 1. High-Level Decoupled System Architecture</a:t>
+              <a:t>Fig. 1. High-Level 3-Tier System Architecture (Next.js, FastAPI, NetworkX, Redis)</a:t>
             </a:r>
           </a:p>
         </p:txBody>
@@ -4869,8 +4869,8 @@
         </p:nvSpPr>
         <p:spPr>
           <a:xfrm>
-            <a:off x="6217920" y="1554480"/>
-            <a:ext cx="5242255" cy="2240280"/>
+            <a:off x="6492240" y="1554480"/>
+            <a:ext cx="4967935" cy="2240280"/>
           </a:xfrm>
           <a:prstGeom prst="rect">
             <a:avLst/>
@@ -4899,14 +4899,14 @@
           </a:fontRef>
         </p:style>
         <p:txBody>
-          <a:bodyPr rtlCol="0" anchor="t" wrap="square" lIns="228600" rIns="228600" tIns="201168" bIns="182880"/>
+          <a:bodyPr rtlCol="0" anchor="t" wrap="square" lIns="228600" rIns="228600" tIns="164592" bIns="164592"/>
           <a:lstStyle/>
           <a:p>
             <a:pPr algn="ctr">
               <a:spcAft>
-                <a:spcPts val="800"/>
+                <a:spcPts val="600"/>
               </a:spcAft>
-              <a:defRPr sz="1400" b="1">
+              <a:defRPr sz="1300" b="1">
                 <a:solidFill>
                   <a:srgbClr val="0F172A"/>
                 </a:solidFill>
@@ -4922,7 +4922,7 @@
               <a:lnSpc>
                 <a:spcPct val="125000"/>
               </a:lnSpc>
-              <a:defRPr sz="1100">
+              <a:defRPr sz="1050">
                 <a:solidFill>
                   <a:srgbClr val="334155"/>
                 </a:solidFill>
@@ -4943,8 +4943,8 @@
         </p:nvSpPr>
         <p:spPr>
           <a:xfrm>
-            <a:off x="6217920" y="1554480"/>
-            <a:ext cx="5242255" cy="73152"/>
+            <a:off x="6492240" y="1554480"/>
+            <a:ext cx="4967935" cy="54864"/>
           </a:xfrm>
           <a:prstGeom prst="rect">
             <a:avLst/>
@@ -4986,8 +4986,8 @@
         </p:nvSpPr>
         <p:spPr>
           <a:xfrm>
-            <a:off x="6217920" y="3977639"/>
-            <a:ext cx="5242255" cy="2240280"/>
+            <a:off x="6492240" y="3977639"/>
+            <a:ext cx="4967935" cy="2240280"/>
           </a:xfrm>
           <a:prstGeom prst="rect">
             <a:avLst/>
@@ -5016,14 +5016,14 @@
           </a:fontRef>
         </p:style>
         <p:txBody>
-          <a:bodyPr rtlCol="0" anchor="t" wrap="square" lIns="228600" rIns="228600" tIns="201168" bIns="182880"/>
+          <a:bodyPr rtlCol="0" anchor="t" wrap="square" lIns="228600" rIns="228600" tIns="164592" bIns="164592"/>
           <a:lstStyle/>
           <a:p>
             <a:pPr algn="ctr">
               <a:spcAft>
-                <a:spcPts val="800"/>
+                <a:spcPts val="600"/>
               </a:spcAft>
-              <a:defRPr sz="1400" b="1">
+              <a:defRPr sz="1300" b="1">
                 <a:solidFill>
                   <a:srgbClr val="0F172A"/>
                 </a:solidFill>
@@ -5039,7 +5039,7 @@
               <a:lnSpc>
                 <a:spcPct val="125000"/>
               </a:lnSpc>
-              <a:defRPr sz="1100">
+              <a:defRPr sz="1050">
                 <a:solidFill>
                   <a:srgbClr val="334155"/>
                 </a:solidFill>
@@ -5060,14 +5060,14 @@
         </p:nvSpPr>
         <p:spPr>
           <a:xfrm>
-            <a:off x="6217920" y="3977639"/>
-            <a:ext cx="5242255" cy="73152"/>
-          </a:xfrm>
-          <a:prstGeom prst="rect">
-            <a:avLst/>
-          </a:prstGeom>
-          <a:solidFill>
-            <a:srgbClr val="1D4ED8"/>
+            <a:off x="6492240" y="3977639"/>
+            <a:ext cx="4967935" cy="54864"/>
+          </a:xfrm>
+          <a:prstGeom prst="rect">
+            <a:avLst/>
+          </a:prstGeom>
+          <a:solidFill>
+            <a:srgbClr val="1E3A8A"/>
           </a:solidFill>
           <a:ln>
             <a:noFill/>
@@ -5206,7 +5206,7 @@
               </a:defRPr>
             </a:pPr>
             <a:r>
-              <a:t>3. Data Flow Architecture &amp; Pipeline</a:t>
+              <a:t>3. Detailed System Design: Level-1 Data Flow Pipeline (DFD)</a:t>
             </a:r>
           </a:p>
           <a:p>
@@ -5219,7 +5219,7 @@
               </a:defRPr>
             </a:pPr>
             <a:r>
-              <a:t>End-to-End Level-1 Data Flow Pipeline from Canvas Topology to Diagnostics</a:t>
+              <a:t>Simulation Execution Pipeline Supporting the Core System Architecture (Non-Architectural Data Flow)</a:t>
             </a:r>
           </a:p>
         </p:txBody>
@@ -5276,7 +5276,7 @@
         <p:spPr>
           <a:xfrm>
             <a:off x="731520" y="1554480"/>
-            <a:ext cx="5212080" cy="4663440"/>
+            <a:ext cx="5577840" cy="4663440"/>
           </a:xfrm>
           <a:prstGeom prst="rect">
             <a:avLst/>
@@ -5328,8 +5328,8 @@
         </p:blipFill>
         <p:spPr>
           <a:xfrm>
-            <a:off x="804672" y="1627632"/>
-            <a:ext cx="5065776" cy="4297680"/>
+            <a:off x="891359" y="1645920"/>
+            <a:ext cx="5258161" cy="4160520"/>
           </a:xfrm>
           <a:prstGeom prst="rect">
             <a:avLst/>
@@ -5345,7 +5345,7 @@
         <p:spPr>
           <a:xfrm>
             <a:off x="731520" y="5897880"/>
-            <a:ext cx="5212080" cy="274320"/>
+            <a:ext cx="5577840" cy="274320"/>
           </a:xfrm>
           <a:prstGeom prst="rect">
             <a:avLst/>
@@ -5361,13 +5361,13 @@
             <a:pPr algn="ctr">
               <a:defRPr sz="950" b="1">
                 <a:solidFill>
-                  <a:srgbClr val="334155"/>
+                  <a:srgbClr val="1E3A8A"/>
                 </a:solidFill>
                 <a:latin typeface="Arial"/>
               </a:defRPr>
             </a:pPr>
             <a:r>
-              <a:t>Fig. 2. Level-1 Data Flow Diagram (DFD)</a:t>
+              <a:t>Fig. 2. Level-1 Data Flow Diagram (DFD) — Discrete Simulation Execution Pipeline</a:t>
             </a:r>
           </a:p>
         </p:txBody>
@@ -5380,8 +5380,8 @@
         </p:nvSpPr>
         <p:spPr>
           <a:xfrm>
-            <a:off x="6217920" y="1554480"/>
-            <a:ext cx="5242255" cy="2240280"/>
+            <a:off x="6492240" y="1554480"/>
+            <a:ext cx="4967935" cy="2240280"/>
           </a:xfrm>
           <a:prstGeom prst="rect">
             <a:avLst/>
@@ -5410,14 +5410,14 @@
           </a:fontRef>
         </p:style>
         <p:txBody>
-          <a:bodyPr rtlCol="0" anchor="t" wrap="square" lIns="228600" rIns="228600" tIns="201168" bIns="182880"/>
+          <a:bodyPr rtlCol="0" anchor="t" wrap="square" lIns="228600" rIns="228600" tIns="164592" bIns="164592"/>
           <a:lstStyle/>
           <a:p>
             <a:pPr algn="ctr">
               <a:spcAft>
-                <a:spcPts val="800"/>
+                <a:spcPts val="600"/>
               </a:spcAft>
-              <a:defRPr sz="1400" b="1">
+              <a:defRPr sz="1300" b="1">
                 <a:solidFill>
                   <a:srgbClr val="0F172A"/>
                 </a:solidFill>
@@ -5433,7 +5433,7 @@
               <a:lnSpc>
                 <a:spcPct val="125000"/>
               </a:lnSpc>
-              <a:defRPr sz="1100">
+              <a:defRPr sz="1050">
                 <a:solidFill>
                   <a:srgbClr val="334155"/>
                 </a:solidFill>
@@ -5454,8 +5454,8 @@
         </p:nvSpPr>
         <p:spPr>
           <a:xfrm>
-            <a:off x="6217920" y="1554480"/>
-            <a:ext cx="5242255" cy="73152"/>
+            <a:off x="6492240" y="1554480"/>
+            <a:ext cx="4967935" cy="54864"/>
           </a:xfrm>
           <a:prstGeom prst="rect">
             <a:avLst/>
@@ -5497,8 +5497,8 @@
         </p:nvSpPr>
         <p:spPr>
           <a:xfrm>
-            <a:off x="6217920" y="3977639"/>
-            <a:ext cx="5242255" cy="2240280"/>
+            <a:off x="6492240" y="3977639"/>
+            <a:ext cx="4967935" cy="2240280"/>
           </a:xfrm>
           <a:prstGeom prst="rect">
             <a:avLst/>
@@ -5527,14 +5527,14 @@
           </a:fontRef>
         </p:style>
         <p:txBody>
-          <a:bodyPr rtlCol="0" anchor="t" wrap="square" lIns="228600" rIns="228600" tIns="201168" bIns="182880"/>
+          <a:bodyPr rtlCol="0" anchor="t" wrap="square" lIns="228600" rIns="228600" tIns="164592" bIns="164592"/>
           <a:lstStyle/>
           <a:p>
             <a:pPr algn="ctr">
               <a:spcAft>
-                <a:spcPts val="800"/>
+                <a:spcPts val="600"/>
               </a:spcAft>
-              <a:defRPr sz="1400" b="1">
+              <a:defRPr sz="1300" b="1">
                 <a:solidFill>
                   <a:srgbClr val="0F172A"/>
                 </a:solidFill>
@@ -5550,7 +5550,7 @@
               <a:lnSpc>
                 <a:spcPct val="125000"/>
               </a:lnSpc>
-              <a:defRPr sz="1100">
+              <a:defRPr sz="1050">
                 <a:solidFill>
                   <a:srgbClr val="334155"/>
                 </a:solidFill>
@@ -5571,14 +5571,14 @@
         </p:nvSpPr>
         <p:spPr>
           <a:xfrm>
-            <a:off x="6217920" y="3977639"/>
-            <a:ext cx="5242255" cy="73152"/>
-          </a:xfrm>
-          <a:prstGeom prst="rect">
-            <a:avLst/>
-          </a:prstGeom>
-          <a:solidFill>
-            <a:srgbClr val="1D4ED8"/>
+            <a:off x="6492240" y="3977639"/>
+            <a:ext cx="4967935" cy="54864"/>
+          </a:xfrm>
+          <a:prstGeom prst="rect">
+            <a:avLst/>
+          </a:prstGeom>
+          <a:solidFill>
+            <a:srgbClr val="1E3A8A"/>
           </a:solidFill>
           <a:ln>
             <a:noFill/>
@@ -5717,7 +5717,7 @@
               </a:defRPr>
             </a:pPr>
             <a:r>
-              <a:t>4. Technical Methodology &amp; Simulation Physics</a:t>
+              <a:t>4. Detailed System Design: Simulation Physics &amp; Node Lifecycle</a:t>
             </a:r>
           </a:p>
           <a:p>
@@ -5730,7 +5730,7 @@
               </a:defRPr>
             </a:pPr>
             <a:r>
-              <a:t>Discrete-Event Queuing Dynamics and 4-Stage Node Finite State Automaton</a:t>
+              <a:t>Mathematical M/M/1 Queuing Dynamics and 4-Stage State Automaton (Component Behavioral Model)</a:t>
             </a:r>
           </a:p>
         </p:txBody>
@@ -5787,7 +5787,7 @@
         <p:spPr>
           <a:xfrm>
             <a:off x="731520" y="1554480"/>
-            <a:ext cx="5212080" cy="4663440"/>
+            <a:ext cx="5577840" cy="4663440"/>
           </a:xfrm>
           <a:prstGeom prst="rect">
             <a:avLst/>
@@ -5839,8 +5839,8 @@
         </p:blipFill>
         <p:spPr>
           <a:xfrm>
-            <a:off x="804672" y="1627632"/>
-            <a:ext cx="5065776" cy="4297680"/>
+            <a:off x="1906505" y="1645920"/>
+            <a:ext cx="3227870" cy="4160520"/>
           </a:xfrm>
           <a:prstGeom prst="rect">
             <a:avLst/>
@@ -5856,7 +5856,7 @@
         <p:spPr>
           <a:xfrm>
             <a:off x="731520" y="5897880"/>
-            <a:ext cx="5212080" cy="274320"/>
+            <a:ext cx="5577840" cy="274320"/>
           </a:xfrm>
           <a:prstGeom prst="rect">
             <a:avLst/>
@@ -5872,13 +5872,13 @@
             <a:pPr algn="ctr">
               <a:defRPr sz="950" b="1">
                 <a:solidFill>
-                  <a:srgbClr val="334155"/>
+                  <a:srgbClr val="1E3A8A"/>
                 </a:solidFill>
                 <a:latin typeface="Arial"/>
               </a:defRPr>
             </a:pPr>
             <a:r>
-              <a:t>Fig. 3. UML Node State Machine Diagram</a:t>
+              <a:t>Fig. 3. UML Node State Machine Diagram — Infrastructure Failure &amp; Recovery Lifecycle</a:t>
             </a:r>
           </a:p>
         </p:txBody>
@@ -5891,8 +5891,8 @@
         </p:nvSpPr>
         <p:spPr>
           <a:xfrm>
-            <a:off x="6217920" y="1554480"/>
-            <a:ext cx="5242255" cy="2240280"/>
+            <a:off x="6492240" y="1554480"/>
+            <a:ext cx="4967935" cy="2240280"/>
           </a:xfrm>
           <a:prstGeom prst="rect">
             <a:avLst/>
@@ -5921,14 +5921,14 @@
           </a:fontRef>
         </p:style>
         <p:txBody>
-          <a:bodyPr rtlCol="0" anchor="t" wrap="square" lIns="228600" rIns="228600" tIns="201168" bIns="182880"/>
+          <a:bodyPr rtlCol="0" anchor="t" wrap="square" lIns="228600" rIns="228600" tIns="164592" bIns="164592"/>
           <a:lstStyle/>
           <a:p>
             <a:pPr algn="ctr">
               <a:spcAft>
-                <a:spcPts val="800"/>
+                <a:spcPts val="600"/>
               </a:spcAft>
-              <a:defRPr sz="1400" b="1">
+              <a:defRPr sz="1300" b="1">
                 <a:solidFill>
                   <a:srgbClr val="0F172A"/>
                 </a:solidFill>
@@ -5944,7 +5944,7 @@
               <a:lnSpc>
                 <a:spcPct val="125000"/>
               </a:lnSpc>
-              <a:defRPr sz="1100">
+              <a:defRPr sz="1050">
                 <a:solidFill>
                   <a:srgbClr val="334155"/>
                 </a:solidFill>
@@ -5965,8 +5965,8 @@
         </p:nvSpPr>
         <p:spPr>
           <a:xfrm>
-            <a:off x="6217920" y="1554480"/>
-            <a:ext cx="5242255" cy="73152"/>
+            <a:off x="6492240" y="1554480"/>
+            <a:ext cx="4967935" cy="54864"/>
           </a:xfrm>
           <a:prstGeom prst="rect">
             <a:avLst/>
@@ -6008,8 +6008,8 @@
         </p:nvSpPr>
         <p:spPr>
           <a:xfrm>
-            <a:off x="6217920" y="3977639"/>
-            <a:ext cx="5242255" cy="2240280"/>
+            <a:off x="6492240" y="3977639"/>
+            <a:ext cx="4967935" cy="2240280"/>
           </a:xfrm>
           <a:prstGeom prst="rect">
             <a:avLst/>
@@ -6038,14 +6038,14 @@
           </a:fontRef>
         </p:style>
         <p:txBody>
-          <a:bodyPr rtlCol="0" anchor="t" wrap="square" lIns="228600" rIns="228600" tIns="201168" bIns="182880"/>
+          <a:bodyPr rtlCol="0" anchor="t" wrap="square" lIns="228600" rIns="228600" tIns="164592" bIns="164592"/>
           <a:lstStyle/>
           <a:p>
             <a:pPr algn="ctr">
               <a:spcAft>
-                <a:spcPts val="800"/>
+                <a:spcPts val="600"/>
               </a:spcAft>
-              <a:defRPr sz="1400" b="1">
+              <a:defRPr sz="1300" b="1">
                 <a:solidFill>
                   <a:srgbClr val="0F172A"/>
                 </a:solidFill>
@@ -6061,7 +6061,7 @@
               <a:lnSpc>
                 <a:spcPct val="125000"/>
               </a:lnSpc>
-              <a:defRPr sz="1100">
+              <a:defRPr sz="1050">
                 <a:solidFill>
                   <a:srgbClr val="334155"/>
                 </a:solidFill>
@@ -6082,14 +6082,14 @@
         </p:nvSpPr>
         <p:spPr>
           <a:xfrm>
-            <a:off x="6217920" y="3977639"/>
-            <a:ext cx="5242255" cy="73152"/>
-          </a:xfrm>
-          <a:prstGeom prst="rect">
-            <a:avLst/>
-          </a:prstGeom>
-          <a:solidFill>
-            <a:srgbClr val="1D4ED8"/>
+            <a:off x="6492240" y="3977639"/>
+            <a:ext cx="4967935" cy="54864"/>
+          </a:xfrm>
+          <a:prstGeom prst="rect">
+            <a:avLst/>
+          </a:prstGeom>
+          <a:solidFill>
+            <a:srgbClr val="1E3A8A"/>
           </a:solidFill>
           <a:ln>
             <a:noFill/>
@@ -6298,7 +6298,7 @@
         <p:spPr>
           <a:xfrm>
             <a:off x="731520" y="1554480"/>
-            <a:ext cx="5212080" cy="4663440"/>
+            <a:ext cx="5577840" cy="4663440"/>
           </a:xfrm>
           <a:prstGeom prst="rect">
             <a:avLst/>
@@ -6350,8 +6350,8 @@
         </p:blipFill>
         <p:spPr>
           <a:xfrm>
-            <a:off x="804672" y="1627632"/>
-            <a:ext cx="5065776" cy="4297680"/>
+            <a:off x="841248" y="1967960"/>
+            <a:ext cx="5358384" cy="3516439"/>
           </a:xfrm>
           <a:prstGeom prst="rect">
             <a:avLst/>
@@ -6367,7 +6367,7 @@
         <p:spPr>
           <a:xfrm>
             <a:off x="731520" y="5897880"/>
-            <a:ext cx="5212080" cy="274320"/>
+            <a:ext cx="5577840" cy="274320"/>
           </a:xfrm>
           <a:prstGeom prst="rect">
             <a:avLst/>
@@ -6383,7 +6383,7 @@
             <a:pPr algn="ctr">
               <a:defRPr sz="950" b="1">
                 <a:solidFill>
-                  <a:srgbClr val="334155"/>
+                  <a:srgbClr val="1E3A8A"/>
                 </a:solidFill>
                 <a:latin typeface="Arial"/>
               </a:defRPr>
@@ -6402,8 +6402,8 @@
         </p:nvSpPr>
         <p:spPr>
           <a:xfrm>
-            <a:off x="6217920" y="1554480"/>
-            <a:ext cx="5242255" cy="2240280"/>
+            <a:off x="6492240" y="1554480"/>
+            <a:ext cx="4967935" cy="2240280"/>
           </a:xfrm>
           <a:prstGeom prst="rect">
             <a:avLst/>
@@ -6432,14 +6432,14 @@
           </a:fontRef>
         </p:style>
         <p:txBody>
-          <a:bodyPr rtlCol="0" anchor="t" wrap="square" lIns="228600" rIns="228600" tIns="201168" bIns="182880"/>
+          <a:bodyPr rtlCol="0" anchor="t" wrap="square" lIns="228600" rIns="228600" tIns="164592" bIns="164592"/>
           <a:lstStyle/>
           <a:p>
             <a:pPr algn="ctr">
               <a:spcAft>
-                <a:spcPts val="800"/>
+                <a:spcPts val="600"/>
               </a:spcAft>
-              <a:defRPr sz="1400" b="1">
+              <a:defRPr sz="1300" b="1">
                 <a:solidFill>
                   <a:srgbClr val="0F172A"/>
                 </a:solidFill>
@@ -6455,7 +6455,7 @@
               <a:lnSpc>
                 <a:spcPct val="125000"/>
               </a:lnSpc>
-              <a:defRPr sz="1100">
+              <a:defRPr sz="1050">
                 <a:solidFill>
                   <a:srgbClr val="334155"/>
                 </a:solidFill>
@@ -6476,8 +6476,8 @@
         </p:nvSpPr>
         <p:spPr>
           <a:xfrm>
-            <a:off x="6217920" y="1554480"/>
-            <a:ext cx="5242255" cy="73152"/>
+            <a:off x="6492240" y="1554480"/>
+            <a:ext cx="4967935" cy="54864"/>
           </a:xfrm>
           <a:prstGeom prst="rect">
             <a:avLst/>
@@ -6519,8 +6519,8 @@
         </p:nvSpPr>
         <p:spPr>
           <a:xfrm>
-            <a:off x="6217920" y="3977639"/>
-            <a:ext cx="5242255" cy="2240280"/>
+            <a:off x="6492240" y="3977639"/>
+            <a:ext cx="4967935" cy="2240280"/>
           </a:xfrm>
           <a:prstGeom prst="rect">
             <a:avLst/>
@@ -6549,14 +6549,14 @@
           </a:fontRef>
         </p:style>
         <p:txBody>
-          <a:bodyPr rtlCol="0" anchor="t" wrap="square" lIns="228600" rIns="228600" tIns="201168" bIns="182880"/>
+          <a:bodyPr rtlCol="0" anchor="t" wrap="square" lIns="228600" rIns="228600" tIns="164592" bIns="164592"/>
           <a:lstStyle/>
           <a:p>
             <a:pPr algn="ctr">
               <a:spcAft>
-                <a:spcPts val="800"/>
+                <a:spcPts val="600"/>
               </a:spcAft>
-              <a:defRPr sz="1400" b="1">
+              <a:defRPr sz="1300" b="1">
                 <a:solidFill>
                   <a:srgbClr val="0F172A"/>
                 </a:solidFill>
@@ -6572,7 +6572,7 @@
               <a:lnSpc>
                 <a:spcPct val="125000"/>
               </a:lnSpc>
-              <a:defRPr sz="1100">
+              <a:defRPr sz="1050">
                 <a:solidFill>
                   <a:srgbClr val="334155"/>
                 </a:solidFill>
@@ -6593,14 +6593,14 @@
         </p:nvSpPr>
         <p:spPr>
           <a:xfrm>
-            <a:off x="6217920" y="3977639"/>
-            <a:ext cx="5242255" cy="73152"/>
-          </a:xfrm>
-          <a:prstGeom prst="rect">
-            <a:avLst/>
-          </a:prstGeom>
-          <a:solidFill>
-            <a:srgbClr val="1D4ED8"/>
+            <a:off x="6492240" y="3977639"/>
+            <a:ext cx="4967935" cy="54864"/>
+          </a:xfrm>
+          <a:prstGeom prst="rect">
+            <a:avLst/>
+          </a:prstGeom>
+          <a:solidFill>
+            <a:srgbClr val="1E3A8A"/>
           </a:solidFill>
           <a:ln>
             <a:noFill/>
@@ -6809,7 +6809,7 @@
         <p:spPr>
           <a:xfrm>
             <a:off x="731520" y="1554480"/>
-            <a:ext cx="5212080" cy="2240280"/>
+            <a:ext cx="5577840" cy="2240280"/>
           </a:xfrm>
           <a:prstGeom prst="rect">
             <a:avLst/>
@@ -6861,8 +6861,8 @@
         </p:blipFill>
         <p:spPr>
           <a:xfrm>
-            <a:off x="804672" y="1627632"/>
-            <a:ext cx="5065776" cy="1874520"/>
+            <a:off x="2018427" y="1645920"/>
+            <a:ext cx="3004025" cy="1737360"/>
           </a:xfrm>
           <a:prstGeom prst="rect">
             <a:avLst/>
@@ -6878,7 +6878,7 @@
         <p:spPr>
           <a:xfrm>
             <a:off x="731520" y="3474720"/>
-            <a:ext cx="5212080" cy="274320"/>
+            <a:ext cx="5577840" cy="274320"/>
           </a:xfrm>
           <a:prstGeom prst="rect">
             <a:avLst/>
@@ -6894,7 +6894,7 @@
             <a:pPr algn="ctr">
               <a:defRPr sz="950" b="1">
                 <a:solidFill>
-                  <a:srgbClr val="334155"/>
+                  <a:srgbClr val="1E3A8A"/>
                 </a:solidFill>
                 <a:latin typeface="Arial"/>
               </a:defRPr>
@@ -6914,7 +6914,7 @@
         <p:spPr>
           <a:xfrm>
             <a:off x="731520" y="3977639"/>
-            <a:ext cx="5212080" cy="2240280"/>
+            <a:ext cx="5577840" cy="2240280"/>
           </a:xfrm>
           <a:prstGeom prst="rect">
             <a:avLst/>
@@ -6966,8 +6966,8 @@
         </p:blipFill>
         <p:spPr>
           <a:xfrm>
-            <a:off x="804672" y="4050791"/>
-            <a:ext cx="5065776" cy="1874520"/>
+            <a:off x="841248" y="4616256"/>
+            <a:ext cx="5358384" cy="643006"/>
           </a:xfrm>
           <a:prstGeom prst="rect">
             <a:avLst/>
@@ -6983,7 +6983,7 @@
         <p:spPr>
           <a:xfrm>
             <a:off x="731520" y="5897879"/>
-            <a:ext cx="5212080" cy="274320"/>
+            <a:ext cx="5577840" cy="274320"/>
           </a:xfrm>
           <a:prstGeom prst="rect">
             <a:avLst/>
@@ -6999,7 +6999,7 @@
             <a:pPr algn="ctr">
               <a:defRPr sz="950" b="1">
                 <a:solidFill>
-                  <a:srgbClr val="334155"/>
+                  <a:srgbClr val="1E3A8A"/>
                 </a:solidFill>
                 <a:latin typeface="Arial"/>
               </a:defRPr>
@@ -7018,8 +7018,8 @@
         </p:nvSpPr>
         <p:spPr>
           <a:xfrm>
-            <a:off x="6217920" y="1554480"/>
-            <a:ext cx="5242255" cy="2240280"/>
+            <a:off x="6492240" y="1554480"/>
+            <a:ext cx="4967935" cy="2240280"/>
           </a:xfrm>
           <a:prstGeom prst="rect">
             <a:avLst/>
@@ -7048,14 +7048,14 @@
           </a:fontRef>
         </p:style>
         <p:txBody>
-          <a:bodyPr rtlCol="0" anchor="t" wrap="square" lIns="228600" rIns="228600" tIns="201168" bIns="182880"/>
+          <a:bodyPr rtlCol="0" anchor="t" wrap="square" lIns="228600" rIns="228600" tIns="164592" bIns="164592"/>
           <a:lstStyle/>
           <a:p>
             <a:pPr algn="ctr">
               <a:spcAft>
-                <a:spcPts val="800"/>
+                <a:spcPts val="600"/>
               </a:spcAft>
-              <a:defRPr sz="1400" b="1">
+              <a:defRPr sz="1300" b="1">
                 <a:solidFill>
                   <a:srgbClr val="0F172A"/>
                 </a:solidFill>
@@ -7071,7 +7071,7 @@
               <a:lnSpc>
                 <a:spcPct val="125000"/>
               </a:lnSpc>
-              <a:defRPr sz="1100">
+              <a:defRPr sz="1050">
                 <a:solidFill>
                   <a:srgbClr val="334155"/>
                 </a:solidFill>
@@ -7092,14 +7092,14 @@
         </p:nvSpPr>
         <p:spPr>
           <a:xfrm>
-            <a:off x="6217920" y="1554480"/>
-            <a:ext cx="5242255" cy="73152"/>
-          </a:xfrm>
-          <a:prstGeom prst="rect">
-            <a:avLst/>
-          </a:prstGeom>
-          <a:solidFill>
-            <a:srgbClr val="DC2626"/>
+            <a:off x="6492240" y="1554480"/>
+            <a:ext cx="4967935" cy="54864"/>
+          </a:xfrm>
+          <a:prstGeom prst="rect">
+            <a:avLst/>
+          </a:prstGeom>
+          <a:solidFill>
+            <a:srgbClr val="1E3A8A"/>
           </a:solidFill>
           <a:ln>
             <a:noFill/>
@@ -7135,8 +7135,8 @@
         </p:nvSpPr>
         <p:spPr>
           <a:xfrm>
-            <a:off x="6217920" y="3977639"/>
-            <a:ext cx="5242255" cy="2240280"/>
+            <a:off x="6492240" y="3977639"/>
+            <a:ext cx="4967935" cy="2240280"/>
           </a:xfrm>
           <a:prstGeom prst="rect">
             <a:avLst/>
@@ -7165,14 +7165,14 @@
           </a:fontRef>
         </p:style>
         <p:txBody>
-          <a:bodyPr rtlCol="0" anchor="t" wrap="square" lIns="228600" rIns="228600" tIns="201168" bIns="182880"/>
+          <a:bodyPr rtlCol="0" anchor="t" wrap="square" lIns="228600" rIns="228600" tIns="164592" bIns="164592"/>
           <a:lstStyle/>
           <a:p>
             <a:pPr algn="ctr">
               <a:spcAft>
-                <a:spcPts val="800"/>
+                <a:spcPts val="600"/>
               </a:spcAft>
-              <a:defRPr sz="1400" b="1">
+              <a:defRPr sz="1300" b="1">
                 <a:solidFill>
                   <a:srgbClr val="0F172A"/>
                 </a:solidFill>
@@ -7188,7 +7188,7 @@
               <a:lnSpc>
                 <a:spcPct val="125000"/>
               </a:lnSpc>
-              <a:defRPr sz="1100">
+              <a:defRPr sz="1050">
                 <a:solidFill>
                   <a:srgbClr val="334155"/>
                 </a:solidFill>
@@ -7209,14 +7209,14 @@
         </p:nvSpPr>
         <p:spPr>
           <a:xfrm>
-            <a:off x="6217920" y="3977639"/>
-            <a:ext cx="5242255" cy="73152"/>
-          </a:xfrm>
-          <a:prstGeom prst="rect">
-            <a:avLst/>
-          </a:prstGeom>
-          <a:solidFill>
-            <a:srgbClr val="1D4ED8"/>
+            <a:off x="6492240" y="3977639"/>
+            <a:ext cx="4967935" cy="54864"/>
+          </a:xfrm>
+          <a:prstGeom prst="rect">
+            <a:avLst/>
+          </a:prstGeom>
+          <a:solidFill>
+            <a:srgbClr val="1E3A8A"/>
           </a:solidFill>
           <a:ln>
             <a:noFill/>
@@ -7425,7 +7425,7 @@
         <p:spPr>
           <a:xfrm>
             <a:off x="731520" y="1554480"/>
-            <a:ext cx="5212080" cy="2240280"/>
+            <a:ext cx="5577840" cy="2240280"/>
           </a:xfrm>
           <a:prstGeom prst="rect">
             <a:avLst/>
@@ -7477,8 +7477,8 @@
         </p:blipFill>
         <p:spPr>
           <a:xfrm>
-            <a:off x="804672" y="1627632"/>
-            <a:ext cx="5065776" cy="1874520"/>
+            <a:off x="2196737" y="1645920"/>
+            <a:ext cx="2647405" cy="1737360"/>
           </a:xfrm>
           <a:prstGeom prst="rect">
             <a:avLst/>
@@ -7494,7 +7494,7 @@
         <p:spPr>
           <a:xfrm>
             <a:off x="731520" y="3474720"/>
-            <a:ext cx="5212080" cy="274320"/>
+            <a:ext cx="5577840" cy="274320"/>
           </a:xfrm>
           <a:prstGeom prst="rect">
             <a:avLst/>
@@ -7510,7 +7510,7 @@
             <a:pPr algn="ctr">
               <a:defRPr sz="950" b="1">
                 <a:solidFill>
-                  <a:srgbClr val="334155"/>
+                  <a:srgbClr val="1E3A8A"/>
                 </a:solidFill>
                 <a:latin typeface="Arial"/>
               </a:defRPr>
@@ -7530,7 +7530,7 @@
         <p:spPr>
           <a:xfrm>
             <a:off x="731520" y="3977639"/>
-            <a:ext cx="5212080" cy="2240280"/>
+            <a:ext cx="5577840" cy="2240280"/>
           </a:xfrm>
           <a:prstGeom prst="rect">
             <a:avLst/>
@@ -7582,8 +7582,8 @@
         </p:blipFill>
         <p:spPr>
           <a:xfrm>
-            <a:off x="804672" y="4050791"/>
-            <a:ext cx="5065776" cy="1874520"/>
+            <a:off x="2196737" y="4069079"/>
+            <a:ext cx="2647405" cy="1737360"/>
           </a:xfrm>
           <a:prstGeom prst="rect">
             <a:avLst/>
@@ -7599,7 +7599,7 @@
         <p:spPr>
           <a:xfrm>
             <a:off x="731520" y="5897879"/>
-            <a:ext cx="5212080" cy="274320"/>
+            <a:ext cx="5577840" cy="274320"/>
           </a:xfrm>
           <a:prstGeom prst="rect">
             <a:avLst/>
@@ -7615,7 +7615,7 @@
             <a:pPr algn="ctr">
               <a:defRPr sz="950" b="1">
                 <a:solidFill>
-                  <a:srgbClr val="334155"/>
+                  <a:srgbClr val="1E3A8A"/>
                 </a:solidFill>
                 <a:latin typeface="Arial"/>
               </a:defRPr>
@@ -7634,8 +7634,8 @@
         </p:nvSpPr>
         <p:spPr>
           <a:xfrm>
-            <a:off x="6217920" y="1554480"/>
-            <a:ext cx="5242255" cy="2240280"/>
+            <a:off x="6492240" y="1554480"/>
+            <a:ext cx="4967935" cy="2240280"/>
           </a:xfrm>
           <a:prstGeom prst="rect">
             <a:avLst/>
@@ -7664,14 +7664,14 @@
           </a:fontRef>
         </p:style>
         <p:txBody>
-          <a:bodyPr rtlCol="0" anchor="t" wrap="square" lIns="228600" rIns="228600" tIns="201168" bIns="182880"/>
+          <a:bodyPr rtlCol="0" anchor="t" wrap="square" lIns="228600" rIns="228600" tIns="164592" bIns="164592"/>
           <a:lstStyle/>
           <a:p>
             <a:pPr algn="ctr">
               <a:spcAft>
-                <a:spcPts val="800"/>
+                <a:spcPts val="600"/>
               </a:spcAft>
-              <a:defRPr sz="1400" b="1">
+              <a:defRPr sz="1300" b="1">
                 <a:solidFill>
                   <a:srgbClr val="0F172A"/>
                 </a:solidFill>
@@ -7687,7 +7687,7 @@
               <a:lnSpc>
                 <a:spcPct val="125000"/>
               </a:lnSpc>
-              <a:defRPr sz="1100">
+              <a:defRPr sz="1050">
                 <a:solidFill>
                   <a:srgbClr val="334155"/>
                 </a:solidFill>
@@ -7708,8 +7708,8 @@
         </p:nvSpPr>
         <p:spPr>
           <a:xfrm>
-            <a:off x="6217920" y="1554480"/>
-            <a:ext cx="5242255" cy="73152"/>
+            <a:off x="6492240" y="1554480"/>
+            <a:ext cx="4967935" cy="54864"/>
           </a:xfrm>
           <a:prstGeom prst="rect">
             <a:avLst/>
@@ -7751,8 +7751,8 @@
         </p:nvSpPr>
         <p:spPr>
           <a:xfrm>
-            <a:off x="6217920" y="3977639"/>
-            <a:ext cx="5242255" cy="2240280"/>
+            <a:off x="6492240" y="3977639"/>
+            <a:ext cx="4967935" cy="2240280"/>
           </a:xfrm>
           <a:prstGeom prst="rect">
             <a:avLst/>
@@ -7781,14 +7781,14 @@
           </a:fontRef>
         </p:style>
         <p:txBody>
-          <a:bodyPr rtlCol="0" anchor="t" wrap="square" lIns="228600" rIns="228600" tIns="201168" bIns="182880"/>
+          <a:bodyPr rtlCol="0" anchor="t" wrap="square" lIns="228600" rIns="228600" tIns="164592" bIns="164592"/>
           <a:lstStyle/>
           <a:p>
             <a:pPr algn="ctr">
               <a:spcAft>
-                <a:spcPts val="800"/>
+                <a:spcPts val="600"/>
               </a:spcAft>
-              <a:defRPr sz="1400" b="1">
+              <a:defRPr sz="1300" b="1">
                 <a:solidFill>
                   <a:srgbClr val="0F172A"/>
                 </a:solidFill>
@@ -7804,7 +7804,7 @@
               <a:lnSpc>
                 <a:spcPct val="125000"/>
               </a:lnSpc>
-              <a:defRPr sz="1100">
+              <a:defRPr sz="1050">
                 <a:solidFill>
                   <a:srgbClr val="334155"/>
                 </a:solidFill>
@@ -7825,14 +7825,14 @@
         </p:nvSpPr>
         <p:spPr>
           <a:xfrm>
-            <a:off x="6217920" y="3977639"/>
-            <a:ext cx="5242255" cy="73152"/>
-          </a:xfrm>
-          <a:prstGeom prst="rect">
-            <a:avLst/>
-          </a:prstGeom>
-          <a:solidFill>
-            <a:srgbClr val="16A34A"/>
+            <a:off x="6492240" y="3977639"/>
+            <a:ext cx="4967935" cy="54864"/>
+          </a:xfrm>
+          <a:prstGeom prst="rect">
+            <a:avLst/>
+          </a:prstGeom>
+          <a:solidFill>
+            <a:srgbClr val="1E3A8A"/>
           </a:solidFill>
           <a:ln>
             <a:noFill/>
@@ -8070,14 +8070,14 @@
           </a:fontRef>
         </p:style>
         <p:txBody>
-          <a:bodyPr rtlCol="0" anchor="t" wrap="square" lIns="228600" rIns="228600" tIns="201168" bIns="182880"/>
+          <a:bodyPr rtlCol="0" anchor="t" wrap="square" lIns="228600" rIns="228600" tIns="164592" bIns="164592"/>
           <a:lstStyle/>
           <a:p>
             <a:pPr algn="ctr">
               <a:spcAft>
-                <a:spcPts val="800"/>
+                <a:spcPts val="600"/>
               </a:spcAft>
-              <a:defRPr sz="1400" b="1">
+              <a:defRPr sz="1300" b="1">
                 <a:solidFill>
                   <a:srgbClr val="0F172A"/>
                 </a:solidFill>
@@ -8093,7 +8093,7 @@
               <a:lnSpc>
                 <a:spcPct val="125000"/>
               </a:lnSpc>
-              <a:defRPr sz="1100">
+              <a:defRPr sz="1050">
                 <a:solidFill>
                   <a:srgbClr val="334155"/>
                 </a:solidFill>
@@ -8115,7 +8115,7 @@
         <p:spPr>
           <a:xfrm>
             <a:off x="731520" y="1554480"/>
-            <a:ext cx="5212080" cy="73152"/>
+            <a:ext cx="5212080" cy="54864"/>
           </a:xfrm>
           <a:prstGeom prst="rect">
             <a:avLst/>
@@ -8187,14 +8187,14 @@
           </a:fontRef>
         </p:style>
         <p:txBody>
-          <a:bodyPr rtlCol="0" anchor="t" wrap="square" lIns="228600" rIns="228600" tIns="201168" bIns="182880"/>
+          <a:bodyPr rtlCol="0" anchor="t" wrap="square" lIns="228600" rIns="228600" tIns="164592" bIns="164592"/>
           <a:lstStyle/>
           <a:p>
             <a:pPr algn="ctr">
               <a:spcAft>
-                <a:spcPts val="800"/>
+                <a:spcPts val="600"/>
               </a:spcAft>
-              <a:defRPr sz="1400" b="1">
+              <a:defRPr sz="1300" b="1">
                 <a:solidFill>
                   <a:srgbClr val="0F172A"/>
                 </a:solidFill>
@@ -8210,7 +8210,7 @@
               <a:lnSpc>
                 <a:spcPct val="125000"/>
               </a:lnSpc>
-              <a:defRPr sz="1100">
+              <a:defRPr sz="1050">
                 <a:solidFill>
                   <a:srgbClr val="334155"/>
                 </a:solidFill>
@@ -8232,13 +8232,13 @@
         <p:spPr>
           <a:xfrm>
             <a:off x="6217920" y="1554480"/>
-            <a:ext cx="5242255" cy="73152"/>
-          </a:xfrm>
-          <a:prstGeom prst="rect">
-            <a:avLst/>
-          </a:prstGeom>
-          <a:solidFill>
-            <a:srgbClr val="1D4ED8"/>
+            <a:ext cx="5242255" cy="54864"/>
+          </a:xfrm>
+          <a:prstGeom prst="rect">
+            <a:avLst/>
+          </a:prstGeom>
+          <a:solidFill>
+            <a:srgbClr val="1E3A8A"/>
           </a:solidFill>
           <a:ln>
             <a:noFill/>
@@ -8304,14 +8304,14 @@
           </a:fontRef>
         </p:style>
         <p:txBody>
-          <a:bodyPr rtlCol="0" anchor="t" wrap="square" lIns="228600" rIns="228600" tIns="201168" bIns="182880"/>
+          <a:bodyPr rtlCol="0" anchor="t" wrap="square" lIns="228600" rIns="228600" tIns="164592" bIns="164592"/>
           <a:lstStyle/>
           <a:p>
             <a:pPr algn="ctr">
               <a:spcAft>
-                <a:spcPts val="800"/>
+                <a:spcPts val="600"/>
               </a:spcAft>
-              <a:defRPr sz="1400" b="1">
+              <a:defRPr sz="1300" b="1">
                 <a:solidFill>
                   <a:srgbClr val="0F172A"/>
                 </a:solidFill>
@@ -8327,7 +8327,7 @@
               <a:lnSpc>
                 <a:spcPct val="125000"/>
               </a:lnSpc>
-              <a:defRPr sz="1100">
+              <a:defRPr sz="1050">
                 <a:solidFill>
                   <a:srgbClr val="334155"/>
                 </a:solidFill>
@@ -8349,13 +8349,13 @@
         <p:spPr>
           <a:xfrm>
             <a:off x="731520" y="3977639"/>
-            <a:ext cx="5212080" cy="73152"/>
-          </a:xfrm>
-          <a:prstGeom prst="rect">
-            <a:avLst/>
-          </a:prstGeom>
-          <a:solidFill>
-            <a:srgbClr val="D97706"/>
+            <a:ext cx="5212080" cy="54864"/>
+          </a:xfrm>
+          <a:prstGeom prst="rect">
+            <a:avLst/>
+          </a:prstGeom>
+          <a:solidFill>
+            <a:srgbClr val="1E3A8A"/>
           </a:solidFill>
           <a:ln>
             <a:noFill/>
@@ -8421,14 +8421,14 @@
           </a:fontRef>
         </p:style>
         <p:txBody>
-          <a:bodyPr rtlCol="0" anchor="t" wrap="square" lIns="228600" rIns="228600" tIns="201168" bIns="182880"/>
+          <a:bodyPr rtlCol="0" anchor="t" wrap="square" lIns="228600" rIns="228600" tIns="164592" bIns="164592"/>
           <a:lstStyle/>
           <a:p>
             <a:pPr algn="ctr">
               <a:spcAft>
-                <a:spcPts val="800"/>
+                <a:spcPts val="600"/>
               </a:spcAft>
-              <a:defRPr sz="1400" b="1">
+              <a:defRPr sz="1300" b="1">
                 <a:solidFill>
                   <a:srgbClr val="0F172A"/>
                 </a:solidFill>
@@ -8444,7 +8444,7 @@
               <a:lnSpc>
                 <a:spcPct val="125000"/>
               </a:lnSpc>
-              <a:defRPr sz="1100">
+              <a:defRPr sz="1050">
                 <a:solidFill>
                   <a:srgbClr val="334155"/>
                 </a:solidFill>
@@ -8466,13 +8466,13 @@
         <p:spPr>
           <a:xfrm>
             <a:off x="6217920" y="3977639"/>
-            <a:ext cx="5242255" cy="73152"/>
-          </a:xfrm>
-          <a:prstGeom prst="rect">
-            <a:avLst/>
-          </a:prstGeom>
-          <a:solidFill>
-            <a:srgbClr val="16A34A"/>
+            <a:ext cx="5242255" cy="54864"/>
+          </a:xfrm>
+          <a:prstGeom prst="rect">
+            <a:avLst/>
+          </a:prstGeom>
+          <a:solidFill>
+            <a:srgbClr val="1E3A8A"/>
           </a:solidFill>
           <a:ln>
             <a:noFill/>

</xml_diff>

<commit_message>
Final submission deliverables: sanitize metadata, add clickable links, and standardize presentation artifacts
</commit_message>
<xml_diff>
--- a/University_Submissions/24BCE1836_NetworkSim_Presentation.pptx
+++ b/University_Submissions/24BCE1836_NetworkSim_Presentation.pptx
@@ -3155,7 +3155,7 @@
             <a:avLst/>
           </a:prstGeom>
           <a:solidFill>
-            <a:srgbClr val="1E3A8A"/>
+            <a:srgbClr val="334155"/>
           </a:solidFill>
           <a:ln>
             <a:noFill/>
@@ -3202,7 +3202,7 @@
         <p:spPr>
           <a:xfrm>
             <a:off x="731520" y="1188720"/>
-            <a:ext cx="10728655" cy="2926080"/>
+            <a:ext cx="10728655" cy="2834640"/>
           </a:xfrm>
           <a:prstGeom prst="rect">
             <a:avLst/>
@@ -3252,11 +3252,11 @@
                 <a:spcPts val="800"/>
               </a:spcBef>
               <a:spcAft>
-                <a:spcPts val="1400"/>
+                <a:spcPts val="1200"/>
               </a:spcAft>
               <a:defRPr sz="1400">
                 <a:solidFill>
-                  <a:srgbClr val="1E3A8A"/>
+                  <a:srgbClr val="334155"/>
                 </a:solidFill>
                 <a:latin typeface="Arial"/>
               </a:defRPr>
@@ -3288,8 +3288,8 @@
         </p:nvSpPr>
         <p:spPr>
           <a:xfrm>
-            <a:off x="731520" y="4297680"/>
-            <a:ext cx="5212080" cy="1920240"/>
+            <a:off x="731520" y="4206240"/>
+            <a:ext cx="5212080" cy="2103120"/>
           </a:xfrm>
           <a:prstGeom prst="rect">
             <a:avLst/>
@@ -3318,12 +3318,12 @@
           </a:fontRef>
         </p:style>
         <p:txBody>
-          <a:bodyPr rtlCol="0" anchor="t" wrap="square" lIns="228600" rIns="228600" tIns="164592" bIns="164592"/>
+          <a:bodyPr rtlCol="0" anchor="t" wrap="square" lIns="274320" rIns="228600" tIns="164592"/>
           <a:lstStyle/>
           <a:p>
             <a:pPr algn="ctr">
               <a:spcAft>
-                <a:spcPts val="600"/>
+                <a:spcPts val="400"/>
               </a:spcAft>
               <a:defRPr sz="1300" b="1">
                 <a:solidFill>
@@ -3337,11 +3337,11 @@
             </a:r>
           </a:p>
           <a:p>
-            <a:pPr algn="l">
+            <a:pPr>
               <a:lnSpc>
                 <a:spcPct val="125000"/>
               </a:lnSpc>
-              <a:defRPr sz="1050">
+              <a:defRPr sz="1000">
                 <a:solidFill>
                   <a:srgbClr val="334155"/>
                 </a:solidFill>
@@ -3357,11 +3357,21 @@
             </a:r>
             <a:br/>
             <a:r>
-              <a:t>Contact: ankur.yadav2024@vitstudent.ac.in</a:t>
+              <a:t>Academic Term: Fall Semester 2026-2027</a:t>
             </a:r>
             <a:br/>
             <a:r>
-              <a:t>Academic Term: Fall Semester 2026-2027</a:t>
+              <a:t>Contact: </a:t>
+            </a:r>
+            <a:r>
+              <a:rPr sz="1000" u="sng">
+                <a:solidFill>
+                  <a:srgbClr val="1D4ED8"/>
+                </a:solidFill>
+                <a:latin typeface="Arial"/>
+                <a:hlinkClick r:id="rId2"/>
+              </a:rPr>
+              <a:t>ankur.yadav2024@vitstudent.ac.in</a:t>
             </a:r>
           </a:p>
         </p:txBody>
@@ -3374,14 +3384,14 @@
         </p:nvSpPr>
         <p:spPr>
           <a:xfrm>
-            <a:off x="731520" y="4297680"/>
-            <a:ext cx="5212080" cy="54864"/>
-          </a:xfrm>
-          <a:prstGeom prst="rect">
-            <a:avLst/>
-          </a:prstGeom>
-          <a:solidFill>
-            <a:srgbClr val="1E3A8A"/>
+            <a:off x="731520" y="4206240"/>
+            <a:ext cx="73152" cy="2103120"/>
+          </a:xfrm>
+          <a:prstGeom prst="rect">
+            <a:avLst/>
+          </a:prstGeom>
+          <a:solidFill>
+            <a:srgbClr val="334155"/>
           </a:solidFill>
           <a:ln>
             <a:noFill/>
@@ -3417,8 +3427,8 @@
         </p:nvSpPr>
         <p:spPr>
           <a:xfrm>
-            <a:off x="6217920" y="4297680"/>
-            <a:ext cx="5242255" cy="1920240"/>
+            <a:off x="6217920" y="4206240"/>
+            <a:ext cx="5242255" cy="2103120"/>
           </a:xfrm>
           <a:prstGeom prst="rect">
             <a:avLst/>
@@ -3447,12 +3457,12 @@
           </a:fontRef>
         </p:style>
         <p:txBody>
-          <a:bodyPr rtlCol="0" anchor="t" wrap="square" lIns="228600" rIns="228600" tIns="164592" bIns="164592"/>
+          <a:bodyPr rtlCol="0" anchor="t" wrap="square" lIns="274320" rIns="228600" tIns="164592"/>
           <a:lstStyle/>
           <a:p>
             <a:pPr algn="ctr">
               <a:spcAft>
-                <a:spcPts val="600"/>
+                <a:spcPts val="400"/>
               </a:spcAft>
               <a:defRPr sz="1300" b="1">
                 <a:solidFill>
@@ -3466,11 +3476,11 @@
             </a:r>
           </a:p>
           <a:p>
-            <a:pPr algn="l">
+            <a:pPr>
               <a:lnSpc>
                 <a:spcPct val="125000"/>
               </a:lnSpc>
-              <a:defRPr sz="1050">
+              <a:defRPr sz="1000">
                 <a:solidFill>
                   <a:srgbClr val="334155"/>
                 </a:solidFill>
@@ -3478,19 +3488,29 @@
               </a:defRPr>
             </a:pPr>
             <a:r>
-              <a:t>GitHub Repository: https://github.com/ankur-on-github/NetworkSim</a:t>
+              <a:t>Core Deliverable: 100% Functional Simulation Engine &amp; Presentation Deck</a:t>
             </a:r>
             <a:br/>
             <a:r>
-              <a:t>Core Deliverable: 100% Functional Simulation Engine &amp; Presentation Deck</a:t>
+              <a:t>Academic Documentation: Springer Conference Proceeding Paper (Review 2)</a:t>
             </a:r>
             <a:br/>
             <a:r>
-              <a:t>Academic Documentation: Springer Conference Proceeding Paper (Review 2)</a:t>
+              <a:t>Docker Orchestration: Next.js + FastAPI + Redis Stack</a:t>
             </a:r>
             <a:br/>
             <a:r>
-              <a:t>Docker Multi-Container Orchestration: Next.js + FastAPI + Redis Stack</a:t>
+              <a:t>Repository Link: </a:t>
+            </a:r>
+            <a:r>
+              <a:rPr sz="1000" b="1" u="sng">
+                <a:solidFill>
+                  <a:srgbClr val="1D4ED8"/>
+                </a:solidFill>
+                <a:latin typeface="Arial"/>
+                <a:hlinkClick r:id="rId3"/>
+              </a:rPr>
+              <a:t>https://github.com/ankur-on-github/NetworkSim</a:t>
             </a:r>
           </a:p>
         </p:txBody>
@@ -3503,14 +3523,14 @@
         </p:nvSpPr>
         <p:spPr>
           <a:xfrm>
-            <a:off x="6217920" y="4297680"/>
-            <a:ext cx="5242255" cy="54864"/>
-          </a:xfrm>
-          <a:prstGeom prst="rect">
-            <a:avLst/>
-          </a:prstGeom>
-          <a:solidFill>
-            <a:srgbClr val="1E3A8A"/>
+            <a:off x="6217920" y="4206240"/>
+            <a:ext cx="73152" cy="2103120"/>
+          </a:xfrm>
+          <a:prstGeom prst="rect">
+            <a:avLst/>
+          </a:prstGeom>
+          <a:solidFill>
+            <a:srgbClr val="334155"/>
           </a:solidFill>
           <a:ln>
             <a:noFill/>
@@ -3535,6 +3555,63 @@
           <a:lstStyle/>
           <a:p>
             <a:pPr algn="ctr"/>
+          </a:p>
+        </p:txBody>
+      </p:sp>
+      <p:sp>
+        <p:nvSpPr>
+          <p:cNvPr id="9" name="Rectangle 8">
+            <a:hlinkClick r:id="rId3"/>
+          </p:cNvPr>
+          <p:cNvSpPr/>
+          <p:nvPr/>
+        </p:nvSpPr>
+        <p:spPr>
+          <a:xfrm>
+            <a:off x="6492240" y="5806440"/>
+            <a:ext cx="4663440" cy="347472"/>
+          </a:xfrm>
+          <a:prstGeom prst="rect">
+            <a:avLst/>
+          </a:prstGeom>
+          <a:solidFill>
+            <a:srgbClr val="F1F5F9"/>
+          </a:solidFill>
+          <a:ln w="12700">
+            <a:solidFill>
+              <a:srgbClr val="CBD5E1"/>
+            </a:solidFill>
+          </a:ln>
+        </p:spPr>
+        <p:style>
+          <a:lnRef idx="1">
+            <a:schemeClr val="accent1"/>
+          </a:lnRef>
+          <a:fillRef idx="3">
+            <a:schemeClr val="accent1"/>
+          </a:fillRef>
+          <a:effectRef idx="2">
+            <a:schemeClr val="accent1"/>
+          </a:effectRef>
+          <a:fontRef idx="minor">
+            <a:schemeClr val="lt1"/>
+          </a:fontRef>
+        </p:style>
+        <p:txBody>
+          <a:bodyPr rtlCol="0" anchor="ctr" lIns="0" rIns="0" tIns="0" bIns="0"/>
+          <a:lstStyle/>
+          <a:p>
+            <a:pPr algn="ctr"/>
+            <a:r>
+              <a:rPr sz="1000" b="1" u="sng">
+                <a:solidFill>
+                  <a:srgbClr val="1D4ED8"/>
+                </a:solidFill>
+                <a:latin typeface="Arial"/>
+                <a:hlinkClick r:id="rId3"/>
+              </a:rPr>
+              <a:t>🔗 Click to Open GitHub Repository: NetworkSim</a:t>
+            </a:r>
           </a:p>
         </p:txBody>
       </p:sp>
@@ -3656,7 +3733,7 @@
             <a:pPr>
               <a:defRPr sz="1100">
                 <a:solidFill>
-                  <a:srgbClr val="334155"/>
+                  <a:srgbClr val="475569"/>
                 </a:solidFill>
                 <a:latin typeface="Arial"/>
               </a:defRPr>
@@ -3676,13 +3753,13 @@
         <p:spPr>
           <a:xfrm>
             <a:off x="731520" y="365760"/>
-            <a:ext cx="137160" cy="914400"/>
-          </a:xfrm>
-          <a:prstGeom prst="rect">
-            <a:avLst/>
-          </a:prstGeom>
-          <a:solidFill>
-            <a:srgbClr val="1E3A8A"/>
+            <a:ext cx="109728" cy="914400"/>
+          </a:xfrm>
+          <a:prstGeom prst="rect">
+            <a:avLst/>
+          </a:prstGeom>
+          <a:solidFill>
+            <a:srgbClr val="334155"/>
           </a:solidFill>
           <a:ln>
             <a:noFill/>
@@ -3748,7 +3825,7 @@
           </a:fontRef>
         </p:style>
         <p:txBody>
-          <a:bodyPr rtlCol="0" anchor="t" wrap="square" lIns="228600" rIns="228600" tIns="164592" bIns="164592"/>
+          <a:bodyPr rtlCol="0" anchor="t" wrap="square" lIns="274320" rIns="228600" tIns="182880" bIns="182880"/>
           <a:lstStyle/>
           <a:p>
             <a:pPr algn="ctr">
@@ -3793,13 +3870,13 @@
         <p:spPr>
           <a:xfrm>
             <a:off x="731520" y="1554480"/>
-            <a:ext cx="3383280" cy="54864"/>
-          </a:xfrm>
-          <a:prstGeom prst="rect">
-            <a:avLst/>
-          </a:prstGeom>
-          <a:solidFill>
-            <a:srgbClr val="1E3A8A"/>
+            <a:ext cx="73152" cy="4663440"/>
+          </a:xfrm>
+          <a:prstGeom prst="rect">
+            <a:avLst/>
+          </a:prstGeom>
+          <a:solidFill>
+            <a:srgbClr val="334155"/>
           </a:solidFill>
           <a:ln>
             <a:noFill/>
@@ -3865,7 +3942,7 @@
           </a:fontRef>
         </p:style>
         <p:txBody>
-          <a:bodyPr rtlCol="0" anchor="t" wrap="square" lIns="228600" rIns="228600" tIns="164592" bIns="164592"/>
+          <a:bodyPr rtlCol="0" anchor="t" wrap="square" lIns="274320" rIns="228600" tIns="182880" bIns="182880"/>
           <a:lstStyle/>
           <a:p>
             <a:pPr algn="ctr">
@@ -3910,13 +3987,13 @@
         <p:spPr>
           <a:xfrm>
             <a:off x="4389120" y="1554480"/>
-            <a:ext cx="3383280" cy="54864"/>
-          </a:xfrm>
-          <a:prstGeom prst="rect">
-            <a:avLst/>
-          </a:prstGeom>
-          <a:solidFill>
-            <a:srgbClr val="1E3A8A"/>
+            <a:ext cx="73152" cy="4663440"/>
+          </a:xfrm>
+          <a:prstGeom prst="rect">
+            <a:avLst/>
+          </a:prstGeom>
+          <a:solidFill>
+            <a:srgbClr val="334155"/>
           </a:solidFill>
           <a:ln>
             <a:noFill/>
@@ -3982,7 +4059,7 @@
           </a:fontRef>
         </p:style>
         <p:txBody>
-          <a:bodyPr rtlCol="0" anchor="t" wrap="square" lIns="228600" rIns="228600" tIns="164592" bIns="164592"/>
+          <a:bodyPr rtlCol="0" anchor="t" wrap="square" lIns="274320" rIns="228600" tIns="182880"/>
           <a:lstStyle/>
           <a:p>
             <a:pPr algn="ctr">
@@ -4001,7 +4078,7 @@
             </a:r>
           </a:p>
           <a:p>
-            <a:pPr algn="l">
+            <a:pPr>
               <a:lnSpc>
                 <a:spcPct val="125000"/>
               </a:lnSpc>
@@ -4013,7 +4090,32 @@
               </a:defRPr>
             </a:pPr>
             <a:r>
-              <a:t>The code, instructions, documentation, and research papers for the second review are on GitHub at https://github.com/ankur-on-github/NetworkSim. By Ankur Yadav, 24BCE1836, VIT Chennai, School of Computer Science and Engineering.</a:t>
+              <a:t>The complete runnable source code, Docker Compose orchestration, experimental validation logs, setup instructions, and research paper documentation for Review 2 are publicly hosted on GitHub.</a:t>
+            </a:r>
+            <a:br/>
+            <a:br/>
+            <a:r>
+              <a:t>Author: Ankur Yadav (24BCE1836)</a:t>
+            </a:r>
+            <a:br/>
+            <a:r>
+              <a:t>School of Computer Science and Engineering, VIT Chennai.</a:t>
+            </a:r>
+            <a:br/>
+            <a:br/>
+            <a:r>
+              <a:t>Direct Repository Access:</a:t>
+            </a:r>
+            <a:br/>
+            <a:r>
+              <a:rPr sz="1000" b="1" u="sng">
+                <a:solidFill>
+                  <a:srgbClr val="1D4ED8"/>
+                </a:solidFill>
+                <a:latin typeface="Arial"/>
+                <a:hlinkClick r:id="rId2"/>
+              </a:rPr>
+              <a:t>https://github.com/ankur-on-github/NetworkSim</a:t>
             </a:r>
           </a:p>
         </p:txBody>
@@ -4027,13 +4129,13 @@
         <p:spPr>
           <a:xfrm>
             <a:off x="8046720" y="1554480"/>
-            <a:ext cx="3413455" cy="54864"/>
-          </a:xfrm>
-          <a:prstGeom prst="rect">
-            <a:avLst/>
-          </a:prstGeom>
-          <a:solidFill>
-            <a:srgbClr val="1E3A8A"/>
+            <a:ext cx="73152" cy="4663440"/>
+          </a:xfrm>
+          <a:prstGeom prst="rect">
+            <a:avLst/>
+          </a:prstGeom>
+          <a:solidFill>
+            <a:srgbClr val="334155"/>
           </a:solidFill>
           <a:ln>
             <a:noFill/>
@@ -4058,6 +4160,63 @@
           <a:lstStyle/>
           <a:p>
             <a:pPr algn="ctr"/>
+          </a:p>
+        </p:txBody>
+      </p:sp>
+      <p:sp>
+        <p:nvSpPr>
+          <p:cNvPr id="11" name="Rectangle 10">
+            <a:hlinkClick r:id="rId2"/>
+          </p:cNvPr>
+          <p:cNvSpPr/>
+          <p:nvPr/>
+        </p:nvSpPr>
+        <p:spPr>
+          <a:xfrm>
+            <a:off x="8275320" y="5623560"/>
+            <a:ext cx="2926080" cy="411480"/>
+          </a:xfrm>
+          <a:prstGeom prst="rect">
+            <a:avLst/>
+          </a:prstGeom>
+          <a:solidFill>
+            <a:srgbClr val="F1F5F9"/>
+          </a:solidFill>
+          <a:ln w="12700">
+            <a:solidFill>
+              <a:srgbClr val="CBD5E1"/>
+            </a:solidFill>
+          </a:ln>
+        </p:spPr>
+        <p:style>
+          <a:lnRef idx="1">
+            <a:schemeClr val="accent1"/>
+          </a:lnRef>
+          <a:fillRef idx="3">
+            <a:schemeClr val="accent1"/>
+          </a:fillRef>
+          <a:effectRef idx="2">
+            <a:schemeClr val="accent1"/>
+          </a:effectRef>
+          <a:fontRef idx="minor">
+            <a:schemeClr val="lt1"/>
+          </a:fontRef>
+        </p:style>
+        <p:txBody>
+          <a:bodyPr rtlCol="0" anchor="ctr" lIns="0" rIns="0" tIns="0" bIns="0"/>
+          <a:lstStyle/>
+          <a:p>
+            <a:pPr algn="ctr"/>
+            <a:r>
+              <a:rPr sz="1000" b="1" u="sng">
+                <a:solidFill>
+                  <a:srgbClr val="1D4ED8"/>
+                </a:solidFill>
+                <a:latin typeface="Arial"/>
+                <a:hlinkClick r:id="rId2"/>
+              </a:rPr>
+              <a:t>🔗 Open GitHub Repository</a:t>
+            </a:r>
           </a:p>
         </p:txBody>
       </p:sp>
@@ -4179,7 +4338,7 @@
             <a:pPr>
               <a:defRPr sz="1100">
                 <a:solidFill>
-                  <a:srgbClr val="334155"/>
+                  <a:srgbClr val="475569"/>
                 </a:solidFill>
                 <a:latin typeface="Arial"/>
               </a:defRPr>
@@ -4199,13 +4358,13 @@
         <p:spPr>
           <a:xfrm>
             <a:off x="731520" y="365760"/>
-            <a:ext cx="137160" cy="914400"/>
-          </a:xfrm>
-          <a:prstGeom prst="rect">
-            <a:avLst/>
-          </a:prstGeom>
-          <a:solidFill>
-            <a:srgbClr val="1E3A8A"/>
+            <a:ext cx="109728" cy="914400"/>
+          </a:xfrm>
+          <a:prstGeom prst="rect">
+            <a:avLst/>
+          </a:prstGeom>
+          <a:solidFill>
+            <a:srgbClr val="334155"/>
           </a:solidFill>
           <a:ln>
             <a:noFill/>
@@ -4271,7 +4430,7 @@
           </a:fontRef>
         </p:style>
         <p:txBody>
-          <a:bodyPr rtlCol="0" anchor="t" wrap="square" lIns="228600" rIns="228600" tIns="164592" bIns="164592"/>
+          <a:bodyPr rtlCol="0" anchor="t" wrap="square" lIns="274320" rIns="228600" tIns="182880" bIns="182880"/>
           <a:lstStyle/>
           <a:p>
             <a:pPr algn="ctr">
@@ -4316,13 +4475,13 @@
         <p:spPr>
           <a:xfrm>
             <a:off x="731520" y="1554480"/>
-            <a:ext cx="3383280" cy="54864"/>
-          </a:xfrm>
-          <a:prstGeom prst="rect">
-            <a:avLst/>
-          </a:prstGeom>
-          <a:solidFill>
-            <a:srgbClr val="1E3A8A"/>
+            <a:ext cx="73152" cy="4663440"/>
+          </a:xfrm>
+          <a:prstGeom prst="rect">
+            <a:avLst/>
+          </a:prstGeom>
+          <a:solidFill>
+            <a:srgbClr val="334155"/>
           </a:solidFill>
           <a:ln>
             <a:noFill/>
@@ -4388,7 +4547,7 @@
           </a:fontRef>
         </p:style>
         <p:txBody>
-          <a:bodyPr rtlCol="0" anchor="t" wrap="square" lIns="228600" rIns="228600" tIns="164592" bIns="164592"/>
+          <a:bodyPr rtlCol="0" anchor="t" wrap="square" lIns="274320" rIns="228600" tIns="182880" bIns="182880"/>
           <a:lstStyle/>
           <a:p>
             <a:pPr algn="ctr">
@@ -4433,13 +4592,13 @@
         <p:spPr>
           <a:xfrm>
             <a:off x="4389120" y="1554480"/>
-            <a:ext cx="3383280" cy="54864"/>
-          </a:xfrm>
-          <a:prstGeom prst="rect">
-            <a:avLst/>
-          </a:prstGeom>
-          <a:solidFill>
-            <a:srgbClr val="1E3A8A"/>
+            <a:ext cx="73152" cy="4663440"/>
+          </a:xfrm>
+          <a:prstGeom prst="rect">
+            <a:avLst/>
+          </a:prstGeom>
+          <a:solidFill>
+            <a:srgbClr val="334155"/>
           </a:solidFill>
           <a:ln>
             <a:noFill/>
@@ -4505,7 +4664,7 @@
           </a:fontRef>
         </p:style>
         <p:txBody>
-          <a:bodyPr rtlCol="0" anchor="t" wrap="square" lIns="228600" rIns="228600" tIns="164592" bIns="164592"/>
+          <a:bodyPr rtlCol="0" anchor="t" wrap="square" lIns="274320" rIns="228600" tIns="182880" bIns="182880"/>
           <a:lstStyle/>
           <a:p>
             <a:pPr algn="ctr">
@@ -4550,13 +4709,13 @@
         <p:spPr>
           <a:xfrm>
             <a:off x="8046720" y="1554480"/>
-            <a:ext cx="3413455" cy="54864"/>
-          </a:xfrm>
-          <a:prstGeom prst="rect">
-            <a:avLst/>
-          </a:prstGeom>
-          <a:solidFill>
-            <a:srgbClr val="1E3A8A"/>
+            <a:ext cx="73152" cy="4663440"/>
+          </a:xfrm>
+          <a:prstGeom prst="rect">
+            <a:avLst/>
+          </a:prstGeom>
+          <a:solidFill>
+            <a:srgbClr val="334155"/>
           </a:solidFill>
           <a:ln>
             <a:noFill/>
@@ -4702,7 +4861,7 @@
             <a:pPr>
               <a:defRPr sz="1100">
                 <a:solidFill>
-                  <a:srgbClr val="334155"/>
+                  <a:srgbClr val="475569"/>
                 </a:solidFill>
                 <a:latin typeface="Arial"/>
               </a:defRPr>
@@ -4722,13 +4881,13 @@
         <p:spPr>
           <a:xfrm>
             <a:off x="731520" y="365760"/>
-            <a:ext cx="137160" cy="914400"/>
-          </a:xfrm>
-          <a:prstGeom prst="rect">
-            <a:avLst/>
-          </a:prstGeom>
-          <a:solidFill>
-            <a:srgbClr val="1E3A8A"/>
+            <a:ext cx="109728" cy="914400"/>
+          </a:xfrm>
+          <a:prstGeom prst="rect">
+            <a:avLst/>
+          </a:prstGeom>
+          <a:solidFill>
+            <a:srgbClr val="334155"/>
           </a:solidFill>
           <a:ln>
             <a:noFill/>
@@ -4850,7 +5009,7 @@
             <a:pPr algn="ctr">
               <a:defRPr sz="950" b="1">
                 <a:solidFill>
-                  <a:srgbClr val="1E3A8A"/>
+                  <a:srgbClr val="334155"/>
                 </a:solidFill>
                 <a:latin typeface="Arial"/>
               </a:defRPr>
@@ -4899,7 +5058,7 @@
           </a:fontRef>
         </p:style>
         <p:txBody>
-          <a:bodyPr rtlCol="0" anchor="t" wrap="square" lIns="228600" rIns="228600" tIns="164592" bIns="164592"/>
+          <a:bodyPr rtlCol="0" anchor="t" wrap="square" lIns="274320" rIns="228600" tIns="182880" bIns="182880"/>
           <a:lstStyle/>
           <a:p>
             <a:pPr algn="ctr">
@@ -4944,13 +5103,13 @@
         <p:spPr>
           <a:xfrm>
             <a:off x="6492240" y="1554480"/>
-            <a:ext cx="4967935" cy="54864"/>
-          </a:xfrm>
-          <a:prstGeom prst="rect">
-            <a:avLst/>
-          </a:prstGeom>
-          <a:solidFill>
-            <a:srgbClr val="1E3A8A"/>
+            <a:ext cx="73152" cy="2240280"/>
+          </a:xfrm>
+          <a:prstGeom prst="rect">
+            <a:avLst/>
+          </a:prstGeom>
+          <a:solidFill>
+            <a:srgbClr val="334155"/>
           </a:solidFill>
           <a:ln>
             <a:noFill/>
@@ -5016,7 +5175,7 @@
           </a:fontRef>
         </p:style>
         <p:txBody>
-          <a:bodyPr rtlCol="0" anchor="t" wrap="square" lIns="228600" rIns="228600" tIns="164592" bIns="164592"/>
+          <a:bodyPr rtlCol="0" anchor="t" wrap="square" lIns="274320" rIns="228600" tIns="182880" bIns="182880"/>
           <a:lstStyle/>
           <a:p>
             <a:pPr algn="ctr">
@@ -5061,13 +5220,13 @@
         <p:spPr>
           <a:xfrm>
             <a:off x="6492240" y="3977639"/>
-            <a:ext cx="4967935" cy="54864"/>
-          </a:xfrm>
-          <a:prstGeom prst="rect">
-            <a:avLst/>
-          </a:prstGeom>
-          <a:solidFill>
-            <a:srgbClr val="1E3A8A"/>
+            <a:ext cx="73152" cy="2240280"/>
+          </a:xfrm>
+          <a:prstGeom prst="rect">
+            <a:avLst/>
+          </a:prstGeom>
+          <a:solidFill>
+            <a:srgbClr val="334155"/>
           </a:solidFill>
           <a:ln>
             <a:noFill/>
@@ -5213,7 +5372,7 @@
             <a:pPr>
               <a:defRPr sz="1100">
                 <a:solidFill>
-                  <a:srgbClr val="334155"/>
+                  <a:srgbClr val="475569"/>
                 </a:solidFill>
                 <a:latin typeface="Arial"/>
               </a:defRPr>
@@ -5233,13 +5392,13 @@
         <p:spPr>
           <a:xfrm>
             <a:off x="731520" y="365760"/>
-            <a:ext cx="137160" cy="914400"/>
-          </a:xfrm>
-          <a:prstGeom prst="rect">
-            <a:avLst/>
-          </a:prstGeom>
-          <a:solidFill>
-            <a:srgbClr val="1E3A8A"/>
+            <a:ext cx="109728" cy="914400"/>
+          </a:xfrm>
+          <a:prstGeom prst="rect">
+            <a:avLst/>
+          </a:prstGeom>
+          <a:solidFill>
+            <a:srgbClr val="334155"/>
           </a:solidFill>
           <a:ln>
             <a:noFill/>
@@ -5361,7 +5520,7 @@
             <a:pPr algn="ctr">
               <a:defRPr sz="950" b="1">
                 <a:solidFill>
-                  <a:srgbClr val="1E3A8A"/>
+                  <a:srgbClr val="334155"/>
                 </a:solidFill>
                 <a:latin typeface="Arial"/>
               </a:defRPr>
@@ -5410,7 +5569,7 @@
           </a:fontRef>
         </p:style>
         <p:txBody>
-          <a:bodyPr rtlCol="0" anchor="t" wrap="square" lIns="228600" rIns="228600" tIns="164592" bIns="164592"/>
+          <a:bodyPr rtlCol="0" anchor="t" wrap="square" lIns="274320" rIns="228600" tIns="182880" bIns="182880"/>
           <a:lstStyle/>
           <a:p>
             <a:pPr algn="ctr">
@@ -5455,13 +5614,13 @@
         <p:spPr>
           <a:xfrm>
             <a:off x="6492240" y="1554480"/>
-            <a:ext cx="4967935" cy="54864"/>
-          </a:xfrm>
-          <a:prstGeom prst="rect">
-            <a:avLst/>
-          </a:prstGeom>
-          <a:solidFill>
-            <a:srgbClr val="1E3A8A"/>
+            <a:ext cx="73152" cy="2240280"/>
+          </a:xfrm>
+          <a:prstGeom prst="rect">
+            <a:avLst/>
+          </a:prstGeom>
+          <a:solidFill>
+            <a:srgbClr val="334155"/>
           </a:solidFill>
           <a:ln>
             <a:noFill/>
@@ -5527,7 +5686,7 @@
           </a:fontRef>
         </p:style>
         <p:txBody>
-          <a:bodyPr rtlCol="0" anchor="t" wrap="square" lIns="228600" rIns="228600" tIns="164592" bIns="164592"/>
+          <a:bodyPr rtlCol="0" anchor="t" wrap="square" lIns="274320" rIns="228600" tIns="182880" bIns="182880"/>
           <a:lstStyle/>
           <a:p>
             <a:pPr algn="ctr">
@@ -5572,13 +5731,13 @@
         <p:spPr>
           <a:xfrm>
             <a:off x="6492240" y="3977639"/>
-            <a:ext cx="4967935" cy="54864"/>
-          </a:xfrm>
-          <a:prstGeom prst="rect">
-            <a:avLst/>
-          </a:prstGeom>
-          <a:solidFill>
-            <a:srgbClr val="1E3A8A"/>
+            <a:ext cx="73152" cy="2240280"/>
+          </a:xfrm>
+          <a:prstGeom prst="rect">
+            <a:avLst/>
+          </a:prstGeom>
+          <a:solidFill>
+            <a:srgbClr val="334155"/>
           </a:solidFill>
           <a:ln>
             <a:noFill/>
@@ -5724,7 +5883,7 @@
             <a:pPr>
               <a:defRPr sz="1100">
                 <a:solidFill>
-                  <a:srgbClr val="334155"/>
+                  <a:srgbClr val="475569"/>
                 </a:solidFill>
                 <a:latin typeface="Arial"/>
               </a:defRPr>
@@ -5744,13 +5903,13 @@
         <p:spPr>
           <a:xfrm>
             <a:off x="731520" y="365760"/>
-            <a:ext cx="137160" cy="914400"/>
-          </a:xfrm>
-          <a:prstGeom prst="rect">
-            <a:avLst/>
-          </a:prstGeom>
-          <a:solidFill>
-            <a:srgbClr val="1E3A8A"/>
+            <a:ext cx="109728" cy="914400"/>
+          </a:xfrm>
+          <a:prstGeom prst="rect">
+            <a:avLst/>
+          </a:prstGeom>
+          <a:solidFill>
+            <a:srgbClr val="334155"/>
           </a:solidFill>
           <a:ln>
             <a:noFill/>
@@ -5872,7 +6031,7 @@
             <a:pPr algn="ctr">
               <a:defRPr sz="950" b="1">
                 <a:solidFill>
-                  <a:srgbClr val="1E3A8A"/>
+                  <a:srgbClr val="334155"/>
                 </a:solidFill>
                 <a:latin typeface="Arial"/>
               </a:defRPr>
@@ -5921,7 +6080,7 @@
           </a:fontRef>
         </p:style>
         <p:txBody>
-          <a:bodyPr rtlCol="0" anchor="t" wrap="square" lIns="228600" rIns="228600" tIns="164592" bIns="164592"/>
+          <a:bodyPr rtlCol="0" anchor="t" wrap="square" lIns="274320" rIns="228600" tIns="182880" bIns="182880"/>
           <a:lstStyle/>
           <a:p>
             <a:pPr algn="ctr">
@@ -5966,13 +6125,13 @@
         <p:spPr>
           <a:xfrm>
             <a:off x="6492240" y="1554480"/>
-            <a:ext cx="4967935" cy="54864"/>
-          </a:xfrm>
-          <a:prstGeom prst="rect">
-            <a:avLst/>
-          </a:prstGeom>
-          <a:solidFill>
-            <a:srgbClr val="1E3A8A"/>
+            <a:ext cx="73152" cy="2240280"/>
+          </a:xfrm>
+          <a:prstGeom prst="rect">
+            <a:avLst/>
+          </a:prstGeom>
+          <a:solidFill>
+            <a:srgbClr val="334155"/>
           </a:solidFill>
           <a:ln>
             <a:noFill/>
@@ -6038,7 +6197,7 @@
           </a:fontRef>
         </p:style>
         <p:txBody>
-          <a:bodyPr rtlCol="0" anchor="t" wrap="square" lIns="228600" rIns="228600" tIns="164592" bIns="164592"/>
+          <a:bodyPr rtlCol="0" anchor="t" wrap="square" lIns="274320" rIns="228600" tIns="182880" bIns="182880"/>
           <a:lstStyle/>
           <a:p>
             <a:pPr algn="ctr">
@@ -6083,13 +6242,13 @@
         <p:spPr>
           <a:xfrm>
             <a:off x="6492240" y="3977639"/>
-            <a:ext cx="4967935" cy="54864"/>
-          </a:xfrm>
-          <a:prstGeom prst="rect">
-            <a:avLst/>
-          </a:prstGeom>
-          <a:solidFill>
-            <a:srgbClr val="1E3A8A"/>
+            <a:ext cx="73152" cy="2240280"/>
+          </a:xfrm>
+          <a:prstGeom prst="rect">
+            <a:avLst/>
+          </a:prstGeom>
+          <a:solidFill>
+            <a:srgbClr val="334155"/>
           </a:solidFill>
           <a:ln>
             <a:noFill/>
@@ -6235,7 +6394,7 @@
             <a:pPr>
               <a:defRPr sz="1100">
                 <a:solidFill>
-                  <a:srgbClr val="334155"/>
+                  <a:srgbClr val="475569"/>
                 </a:solidFill>
                 <a:latin typeface="Arial"/>
               </a:defRPr>
@@ -6255,13 +6414,13 @@
         <p:spPr>
           <a:xfrm>
             <a:off x="731520" y="365760"/>
-            <a:ext cx="137160" cy="914400"/>
-          </a:xfrm>
-          <a:prstGeom prst="rect">
-            <a:avLst/>
-          </a:prstGeom>
-          <a:solidFill>
-            <a:srgbClr val="1E3A8A"/>
+            <a:ext cx="109728" cy="914400"/>
+          </a:xfrm>
+          <a:prstGeom prst="rect">
+            <a:avLst/>
+          </a:prstGeom>
+          <a:solidFill>
+            <a:srgbClr val="334155"/>
           </a:solidFill>
           <a:ln>
             <a:noFill/>
@@ -6383,7 +6542,7 @@
             <a:pPr algn="ctr">
               <a:defRPr sz="950" b="1">
                 <a:solidFill>
-                  <a:srgbClr val="1E3A8A"/>
+                  <a:srgbClr val="334155"/>
                 </a:solidFill>
                 <a:latin typeface="Arial"/>
               </a:defRPr>
@@ -6432,7 +6591,7 @@
           </a:fontRef>
         </p:style>
         <p:txBody>
-          <a:bodyPr rtlCol="0" anchor="t" wrap="square" lIns="228600" rIns="228600" tIns="164592" bIns="164592"/>
+          <a:bodyPr rtlCol="0" anchor="t" wrap="square" lIns="274320" rIns="228600" tIns="182880" bIns="182880"/>
           <a:lstStyle/>
           <a:p>
             <a:pPr algn="ctr">
@@ -6477,13 +6636,13 @@
         <p:spPr>
           <a:xfrm>
             <a:off x="6492240" y="1554480"/>
-            <a:ext cx="4967935" cy="54864"/>
-          </a:xfrm>
-          <a:prstGeom prst="rect">
-            <a:avLst/>
-          </a:prstGeom>
-          <a:solidFill>
-            <a:srgbClr val="1E3A8A"/>
+            <a:ext cx="73152" cy="2240280"/>
+          </a:xfrm>
+          <a:prstGeom prst="rect">
+            <a:avLst/>
+          </a:prstGeom>
+          <a:solidFill>
+            <a:srgbClr val="334155"/>
           </a:solidFill>
           <a:ln>
             <a:noFill/>
@@ -6549,7 +6708,7 @@
           </a:fontRef>
         </p:style>
         <p:txBody>
-          <a:bodyPr rtlCol="0" anchor="t" wrap="square" lIns="228600" rIns="228600" tIns="164592" bIns="164592"/>
+          <a:bodyPr rtlCol="0" anchor="t" wrap="square" lIns="274320" rIns="228600" tIns="182880" bIns="182880"/>
           <a:lstStyle/>
           <a:p>
             <a:pPr algn="ctr">
@@ -6594,13 +6753,13 @@
         <p:spPr>
           <a:xfrm>
             <a:off x="6492240" y="3977639"/>
-            <a:ext cx="4967935" cy="54864"/>
-          </a:xfrm>
-          <a:prstGeom prst="rect">
-            <a:avLst/>
-          </a:prstGeom>
-          <a:solidFill>
-            <a:srgbClr val="1E3A8A"/>
+            <a:ext cx="73152" cy="2240280"/>
+          </a:xfrm>
+          <a:prstGeom prst="rect">
+            <a:avLst/>
+          </a:prstGeom>
+          <a:solidFill>
+            <a:srgbClr val="334155"/>
           </a:solidFill>
           <a:ln>
             <a:noFill/>
@@ -6746,7 +6905,7 @@
             <a:pPr>
               <a:defRPr sz="1100">
                 <a:solidFill>
-                  <a:srgbClr val="334155"/>
+                  <a:srgbClr val="475569"/>
                 </a:solidFill>
                 <a:latin typeface="Arial"/>
               </a:defRPr>
@@ -6766,13 +6925,13 @@
         <p:spPr>
           <a:xfrm>
             <a:off x="731520" y="365760"/>
-            <a:ext cx="137160" cy="914400"/>
-          </a:xfrm>
-          <a:prstGeom prst="rect">
-            <a:avLst/>
-          </a:prstGeom>
-          <a:solidFill>
-            <a:srgbClr val="1E3A8A"/>
+            <a:ext cx="109728" cy="914400"/>
+          </a:xfrm>
+          <a:prstGeom prst="rect">
+            <a:avLst/>
+          </a:prstGeom>
+          <a:solidFill>
+            <a:srgbClr val="334155"/>
           </a:solidFill>
           <a:ln>
             <a:noFill/>
@@ -6894,7 +7053,7 @@
             <a:pPr algn="ctr">
               <a:defRPr sz="950" b="1">
                 <a:solidFill>
-                  <a:srgbClr val="1E3A8A"/>
+                  <a:srgbClr val="334155"/>
                 </a:solidFill>
                 <a:latin typeface="Arial"/>
               </a:defRPr>
@@ -6999,7 +7158,7 @@
             <a:pPr algn="ctr">
               <a:defRPr sz="950" b="1">
                 <a:solidFill>
-                  <a:srgbClr val="1E3A8A"/>
+                  <a:srgbClr val="334155"/>
                 </a:solidFill>
                 <a:latin typeface="Arial"/>
               </a:defRPr>
@@ -7048,7 +7207,7 @@
           </a:fontRef>
         </p:style>
         <p:txBody>
-          <a:bodyPr rtlCol="0" anchor="t" wrap="square" lIns="228600" rIns="228600" tIns="164592" bIns="164592"/>
+          <a:bodyPr rtlCol="0" anchor="t" wrap="square" lIns="274320" rIns="228600" tIns="182880" bIns="182880"/>
           <a:lstStyle/>
           <a:p>
             <a:pPr algn="ctr">
@@ -7093,13 +7252,13 @@
         <p:spPr>
           <a:xfrm>
             <a:off x="6492240" y="1554480"/>
-            <a:ext cx="4967935" cy="54864"/>
-          </a:xfrm>
-          <a:prstGeom prst="rect">
-            <a:avLst/>
-          </a:prstGeom>
-          <a:solidFill>
-            <a:srgbClr val="1E3A8A"/>
+            <a:ext cx="73152" cy="2240280"/>
+          </a:xfrm>
+          <a:prstGeom prst="rect">
+            <a:avLst/>
+          </a:prstGeom>
+          <a:solidFill>
+            <a:srgbClr val="334155"/>
           </a:solidFill>
           <a:ln>
             <a:noFill/>
@@ -7165,7 +7324,7 @@
           </a:fontRef>
         </p:style>
         <p:txBody>
-          <a:bodyPr rtlCol="0" anchor="t" wrap="square" lIns="228600" rIns="228600" tIns="164592" bIns="164592"/>
+          <a:bodyPr rtlCol="0" anchor="t" wrap="square" lIns="274320" rIns="228600" tIns="182880" bIns="182880"/>
           <a:lstStyle/>
           <a:p>
             <a:pPr algn="ctr">
@@ -7210,13 +7369,13 @@
         <p:spPr>
           <a:xfrm>
             <a:off x="6492240" y="3977639"/>
-            <a:ext cx="4967935" cy="54864"/>
-          </a:xfrm>
-          <a:prstGeom prst="rect">
-            <a:avLst/>
-          </a:prstGeom>
-          <a:solidFill>
-            <a:srgbClr val="1E3A8A"/>
+            <a:ext cx="73152" cy="2240280"/>
+          </a:xfrm>
+          <a:prstGeom prst="rect">
+            <a:avLst/>
+          </a:prstGeom>
+          <a:solidFill>
+            <a:srgbClr val="334155"/>
           </a:solidFill>
           <a:ln>
             <a:noFill/>
@@ -7362,7 +7521,7 @@
             <a:pPr>
               <a:defRPr sz="1100">
                 <a:solidFill>
-                  <a:srgbClr val="334155"/>
+                  <a:srgbClr val="475569"/>
                 </a:solidFill>
                 <a:latin typeface="Arial"/>
               </a:defRPr>
@@ -7382,13 +7541,13 @@
         <p:spPr>
           <a:xfrm>
             <a:off x="731520" y="365760"/>
-            <a:ext cx="137160" cy="914400"/>
-          </a:xfrm>
-          <a:prstGeom prst="rect">
-            <a:avLst/>
-          </a:prstGeom>
-          <a:solidFill>
-            <a:srgbClr val="1E3A8A"/>
+            <a:ext cx="109728" cy="914400"/>
+          </a:xfrm>
+          <a:prstGeom prst="rect">
+            <a:avLst/>
+          </a:prstGeom>
+          <a:solidFill>
+            <a:srgbClr val="334155"/>
           </a:solidFill>
           <a:ln>
             <a:noFill/>
@@ -7510,7 +7669,7 @@
             <a:pPr algn="ctr">
               <a:defRPr sz="950" b="1">
                 <a:solidFill>
-                  <a:srgbClr val="1E3A8A"/>
+                  <a:srgbClr val="334155"/>
                 </a:solidFill>
                 <a:latin typeface="Arial"/>
               </a:defRPr>
@@ -7615,7 +7774,7 @@
             <a:pPr algn="ctr">
               <a:defRPr sz="950" b="1">
                 <a:solidFill>
-                  <a:srgbClr val="1E3A8A"/>
+                  <a:srgbClr val="334155"/>
                 </a:solidFill>
                 <a:latin typeface="Arial"/>
               </a:defRPr>
@@ -7664,7 +7823,7 @@
           </a:fontRef>
         </p:style>
         <p:txBody>
-          <a:bodyPr rtlCol="0" anchor="t" wrap="square" lIns="228600" rIns="228600" tIns="164592" bIns="164592"/>
+          <a:bodyPr rtlCol="0" anchor="t" wrap="square" lIns="274320" rIns="228600" tIns="182880" bIns="182880"/>
           <a:lstStyle/>
           <a:p>
             <a:pPr algn="ctr">
@@ -7709,13 +7868,13 @@
         <p:spPr>
           <a:xfrm>
             <a:off x="6492240" y="1554480"/>
-            <a:ext cx="4967935" cy="54864"/>
-          </a:xfrm>
-          <a:prstGeom prst="rect">
-            <a:avLst/>
-          </a:prstGeom>
-          <a:solidFill>
-            <a:srgbClr val="1E3A8A"/>
+            <a:ext cx="73152" cy="2240280"/>
+          </a:xfrm>
+          <a:prstGeom prst="rect">
+            <a:avLst/>
+          </a:prstGeom>
+          <a:solidFill>
+            <a:srgbClr val="334155"/>
           </a:solidFill>
           <a:ln>
             <a:noFill/>
@@ -7781,7 +7940,7 @@
           </a:fontRef>
         </p:style>
         <p:txBody>
-          <a:bodyPr rtlCol="0" anchor="t" wrap="square" lIns="228600" rIns="228600" tIns="164592" bIns="164592"/>
+          <a:bodyPr rtlCol="0" anchor="t" wrap="square" lIns="274320" rIns="228600" tIns="182880" bIns="182880"/>
           <a:lstStyle/>
           <a:p>
             <a:pPr algn="ctr">
@@ -7826,13 +7985,13 @@
         <p:spPr>
           <a:xfrm>
             <a:off x="6492240" y="3977639"/>
-            <a:ext cx="4967935" cy="54864"/>
-          </a:xfrm>
-          <a:prstGeom prst="rect">
-            <a:avLst/>
-          </a:prstGeom>
-          <a:solidFill>
-            <a:srgbClr val="1E3A8A"/>
+            <a:ext cx="73152" cy="2240280"/>
+          </a:xfrm>
+          <a:prstGeom prst="rect">
+            <a:avLst/>
+          </a:prstGeom>
+          <a:solidFill>
+            <a:srgbClr val="334155"/>
           </a:solidFill>
           <a:ln>
             <a:noFill/>
@@ -7978,7 +8137,7 @@
             <a:pPr>
               <a:defRPr sz="1100">
                 <a:solidFill>
-                  <a:srgbClr val="334155"/>
+                  <a:srgbClr val="475569"/>
                 </a:solidFill>
                 <a:latin typeface="Arial"/>
               </a:defRPr>
@@ -7998,13 +8157,13 @@
         <p:spPr>
           <a:xfrm>
             <a:off x="731520" y="365760"/>
-            <a:ext cx="137160" cy="914400"/>
-          </a:xfrm>
-          <a:prstGeom prst="rect">
-            <a:avLst/>
-          </a:prstGeom>
-          <a:solidFill>
-            <a:srgbClr val="1E3A8A"/>
+            <a:ext cx="109728" cy="914400"/>
+          </a:xfrm>
+          <a:prstGeom prst="rect">
+            <a:avLst/>
+          </a:prstGeom>
+          <a:solidFill>
+            <a:srgbClr val="334155"/>
           </a:solidFill>
           <a:ln>
             <a:noFill/>
@@ -8070,7 +8229,7 @@
           </a:fontRef>
         </p:style>
         <p:txBody>
-          <a:bodyPr rtlCol="0" anchor="t" wrap="square" lIns="228600" rIns="228600" tIns="164592" bIns="164592"/>
+          <a:bodyPr rtlCol="0" anchor="t" wrap="square" lIns="274320" rIns="228600" tIns="182880" bIns="182880"/>
           <a:lstStyle/>
           <a:p>
             <a:pPr algn="ctr">
@@ -8115,13 +8274,13 @@
         <p:spPr>
           <a:xfrm>
             <a:off x="731520" y="1554480"/>
-            <a:ext cx="5212080" cy="54864"/>
-          </a:xfrm>
-          <a:prstGeom prst="rect">
-            <a:avLst/>
-          </a:prstGeom>
-          <a:solidFill>
-            <a:srgbClr val="1E3A8A"/>
+            <a:ext cx="73152" cy="2240280"/>
+          </a:xfrm>
+          <a:prstGeom prst="rect">
+            <a:avLst/>
+          </a:prstGeom>
+          <a:solidFill>
+            <a:srgbClr val="334155"/>
           </a:solidFill>
           <a:ln>
             <a:noFill/>
@@ -8187,7 +8346,7 @@
           </a:fontRef>
         </p:style>
         <p:txBody>
-          <a:bodyPr rtlCol="0" anchor="t" wrap="square" lIns="228600" rIns="228600" tIns="164592" bIns="164592"/>
+          <a:bodyPr rtlCol="0" anchor="t" wrap="square" lIns="274320" rIns="228600" tIns="182880" bIns="182880"/>
           <a:lstStyle/>
           <a:p>
             <a:pPr algn="ctr">
@@ -8232,13 +8391,13 @@
         <p:spPr>
           <a:xfrm>
             <a:off x="6217920" y="1554480"/>
-            <a:ext cx="5242255" cy="54864"/>
-          </a:xfrm>
-          <a:prstGeom prst="rect">
-            <a:avLst/>
-          </a:prstGeom>
-          <a:solidFill>
-            <a:srgbClr val="1E3A8A"/>
+            <a:ext cx="73152" cy="2240280"/>
+          </a:xfrm>
+          <a:prstGeom prst="rect">
+            <a:avLst/>
+          </a:prstGeom>
+          <a:solidFill>
+            <a:srgbClr val="334155"/>
           </a:solidFill>
           <a:ln>
             <a:noFill/>
@@ -8304,7 +8463,7 @@
           </a:fontRef>
         </p:style>
         <p:txBody>
-          <a:bodyPr rtlCol="0" anchor="t" wrap="square" lIns="228600" rIns="228600" tIns="164592" bIns="164592"/>
+          <a:bodyPr rtlCol="0" anchor="t" wrap="square" lIns="274320" rIns="228600" tIns="182880" bIns="182880"/>
           <a:lstStyle/>
           <a:p>
             <a:pPr algn="ctr">
@@ -8349,13 +8508,13 @@
         <p:spPr>
           <a:xfrm>
             <a:off x="731520" y="3977639"/>
-            <a:ext cx="5212080" cy="54864"/>
-          </a:xfrm>
-          <a:prstGeom prst="rect">
-            <a:avLst/>
-          </a:prstGeom>
-          <a:solidFill>
-            <a:srgbClr val="1E3A8A"/>
+            <a:ext cx="73152" cy="2240280"/>
+          </a:xfrm>
+          <a:prstGeom prst="rect">
+            <a:avLst/>
+          </a:prstGeom>
+          <a:solidFill>
+            <a:srgbClr val="334155"/>
           </a:solidFill>
           <a:ln>
             <a:noFill/>
@@ -8421,7 +8580,7 @@
           </a:fontRef>
         </p:style>
         <p:txBody>
-          <a:bodyPr rtlCol="0" anchor="t" wrap="square" lIns="228600" rIns="228600" tIns="164592" bIns="164592"/>
+          <a:bodyPr rtlCol="0" anchor="t" wrap="square" lIns="274320" rIns="228600" tIns="182880" bIns="182880"/>
           <a:lstStyle/>
           <a:p>
             <a:pPr algn="ctr">
@@ -8466,13 +8625,13 @@
         <p:spPr>
           <a:xfrm>
             <a:off x="6217920" y="3977639"/>
-            <a:ext cx="5242255" cy="54864"/>
-          </a:xfrm>
-          <a:prstGeom prst="rect">
-            <a:avLst/>
-          </a:prstGeom>
-          <a:solidFill>
-            <a:srgbClr val="1E3A8A"/>
+            <a:ext cx="73152" cy="2240280"/>
+          </a:xfrm>
+          <a:prstGeom prst="rect">
+            <a:avLst/>
+          </a:prstGeom>
+          <a:solidFill>
+            <a:srgbClr val="334155"/>
           </a:solidFill>
           <a:ln>
             <a:noFill/>

</xml_diff>